<commit_message>
Restore PowerScout photos, H-E-B logo, and generic callouts
</commit_message>
<xml_diff>
--- a/docs/component-library/Singh360_Component_Library_Edge.pptx
+++ b/docs/component-library/Singh360_Component_Library_Edge.pptx
@@ -24,7 +24,6 @@
     <p:sldId id="272" r:id="rId23"/>
     <p:sldId id="273" r:id="rId24"/>
     <p:sldId id="274" r:id="rId25"/>
-    <p:sldId id="275" r:id="rId26"/>
   </p:sldIdLst>
   <p:sldSz cx="15544800" cy="10058400" type="screen4x3"/>
   <p:notesSz cx="6858000" cy="9144000"/>
@@ -10386,7 +10385,7 @@
               </a:defRPr>
             </a:pPr>
             <a:r>
-              <a:t>Amber Alarm Strobe Callout</a:t>
+              <a:t>Callout Number 1</a:t>
             </a:r>
           </a:p>
           <a:p>
@@ -10399,7 +10398,7 @@
               </a:defRPr>
             </a:pPr>
             <a:r>
-              <a:t>8</a:t>
+              <a:t>1</a:t>
             </a:r>
           </a:p>
         </p:txBody>
@@ -10477,7 +10476,7 @@
               </a:defRPr>
             </a:pPr>
             <a:r>
-              <a:t>Amber Alarm Strobe Callout</a:t>
+              <a:t>Callout Number 10</a:t>
             </a:r>
           </a:p>
           <a:p>
@@ -10490,7 +10489,7 @@
               </a:defRPr>
             </a:pPr>
             <a:r>
-              <a:t>8</a:t>
+              <a:t>10</a:t>
             </a:r>
           </a:p>
         </p:txBody>
@@ -10568,7 +10567,7 @@
               </a:defRPr>
             </a:pPr>
             <a:r>
-              <a:t>Computer Room Temperature Probe Callout</a:t>
+              <a:t>Callout Number 11</a:t>
             </a:r>
           </a:p>
           <a:p>
@@ -10659,7 +10658,7 @@
               </a:defRPr>
             </a:pPr>
             <a:r>
-              <a:t>Computer Room Temperature Probe Callout</a:t>
+              <a:t>Callout Number 12</a:t>
             </a:r>
           </a:p>
           <a:p>
@@ -10672,7 +10671,7 @@
               </a:defRPr>
             </a:pPr>
             <a:r>
-              <a:t>11</a:t>
+              <a:t>12</a:t>
             </a:r>
           </a:p>
         </p:txBody>
@@ -10750,7 +10749,20 @@
               </a:defRPr>
             </a:pPr>
             <a:r>
-              <a:t>DA Door Open Horn/Strobe</a:t>
+              <a:t>Callout Number 2</a:t>
+            </a:r>
+          </a:p>
+          <a:p>
+            <a:pPr algn="ctr">
+              <a:defRPr sz="700">
+                <a:solidFill>
+                  <a:srgbClr val="5F646E"/>
+                </a:solidFill>
+                <a:latin typeface="Arial"/>
+              </a:defRPr>
+            </a:pPr>
+            <a:r>
+              <a:t>2</a:t>
             </a:r>
           </a:p>
         </p:txBody>
@@ -10828,7 +10840,7 @@
               </a:defRPr>
             </a:pPr>
             <a:r>
-              <a:t>Data Manager Location Callout</a:t>
+              <a:t>Callout Number 3</a:t>
             </a:r>
           </a:p>
           <a:p>
@@ -10841,7 +10853,7 @@
               </a:defRPr>
             </a:pPr>
             <a:r>
-              <a:t>1</a:t>
+              <a:t>3</a:t>
             </a:r>
           </a:p>
         </p:txBody>
@@ -10919,7 +10931,7 @@
               </a:defRPr>
             </a:pPr>
             <a:r>
-              <a:t>Data Manager Location Callout</a:t>
+              <a:t>Callout Number 4</a:t>
             </a:r>
           </a:p>
           <a:p>
@@ -10932,7 +10944,7 @@
               </a:defRPr>
             </a:pPr>
             <a:r>
-              <a:t>1</a:t>
+              <a:t>4</a:t>
             </a:r>
           </a:p>
         </p:txBody>
@@ -11010,7 +11022,7 @@
               </a:defRPr>
             </a:pPr>
             <a:r>
-              <a:t>Dimming Zone Marker</a:t>
+              <a:t>Callout Number 5</a:t>
             </a:r>
           </a:p>
           <a:p>
@@ -11023,7 +11035,7 @@
               </a:defRPr>
             </a:pPr>
             <a:r>
-              <a:t>DZ</a:t>
+              <a:t>5</a:t>
             </a:r>
           </a:p>
         </p:txBody>
@@ -11073,33 +11085,9 @@
           </a:p>
         </p:txBody>
       </p:sp>
-      <p:pic>
-        <p:nvPicPr>
-          <p:cNvPr id="21" name="S360_COMPONENT_ID=generic-din-rail|VARIANT=edge" descr="generic-din-rail__lineart.png"/>
-          <p:cNvPicPr>
-            <a:picLocks noChangeAspect="1"/>
-          </p:cNvPicPr>
-          <p:nvPr/>
-        </p:nvPicPr>
-        <p:blipFill>
-          <a:blip r:embed="rId2"/>
-          <a:stretch>
-            <a:fillRect/>
-          </a:stretch>
-        </p:blipFill>
-        <p:spPr>
-          <a:xfrm>
-            <a:off x="10413873" y="4680585"/>
-            <a:ext cx="514350" cy="514350"/>
-          </a:xfrm>
-          <a:prstGeom prst="rect">
-            <a:avLst/>
-          </a:prstGeom>
-        </p:spPr>
-      </p:pic>
-      <p:sp>
-        <p:nvSpPr>
-          <p:cNvPr id="22" name="TextBox 21"/>
+      <p:sp>
+        <p:nvSpPr>
+          <p:cNvPr id="21" name="TextBox 20"/>
           <p:cNvSpPr txBox="1"/>
           <p:nvPr/>
         </p:nvSpPr>
@@ -11125,14 +11113,27 @@
               </a:defRPr>
             </a:pPr>
             <a:r>
-              <a:t>DIN Rail</a:t>
-            </a:r>
-          </a:p>
-        </p:txBody>
-      </p:sp>
-      <p:sp>
-        <p:nvSpPr>
-          <p:cNvPr id="23" name="Rectangle 22"/>
+              <a:t>Callout Number 6</a:t>
+            </a:r>
+          </a:p>
+          <a:p>
+            <a:pPr algn="ctr">
+              <a:defRPr sz="700">
+                <a:solidFill>
+                  <a:srgbClr val="5F646E"/>
+                </a:solidFill>
+                <a:latin typeface="Arial"/>
+              </a:defRPr>
+            </a:pPr>
+            <a:r>
+              <a:t>6</a:t>
+            </a:r>
+          </a:p>
+        </p:txBody>
+      </p:sp>
+      <p:sp>
+        <p:nvSpPr>
+          <p:cNvPr id="22" name="Rectangle 21"/>
           <p:cNvSpPr/>
           <p:nvPr/>
         </p:nvSpPr>
@@ -11177,7 +11178,7 @@
       </p:sp>
       <p:sp>
         <p:nvSpPr>
-          <p:cNvPr id="24" name="TextBox 23"/>
+          <p:cNvPr id="23" name="TextBox 22"/>
           <p:cNvSpPr txBox="1"/>
           <p:nvPr/>
         </p:nvSpPr>
@@ -11203,14 +11204,27 @@
               </a:defRPr>
             </a:pPr>
             <a:r>
-              <a:t>DS Defrost Sensor</a:t>
-            </a:r>
-          </a:p>
-        </p:txBody>
-      </p:sp>
-      <p:sp>
-        <p:nvSpPr>
-          <p:cNvPr id="25" name="Rectangle 24"/>
+              <a:t>Callout Number 7</a:t>
+            </a:r>
+          </a:p>
+          <a:p>
+            <a:pPr algn="ctr">
+              <a:defRPr sz="700">
+                <a:solidFill>
+                  <a:srgbClr val="5F646E"/>
+                </a:solidFill>
+                <a:latin typeface="Arial"/>
+              </a:defRPr>
+            </a:pPr>
+            <a:r>
+              <a:t>7</a:t>
+            </a:r>
+          </a:p>
+        </p:txBody>
+      </p:sp>
+      <p:sp>
+        <p:nvSpPr>
+          <p:cNvPr id="24" name="Rectangle 23"/>
           <p:cNvSpPr/>
           <p:nvPr/>
         </p:nvSpPr>
@@ -11255,7 +11269,7 @@
       </p:sp>
       <p:sp>
         <p:nvSpPr>
-          <p:cNvPr id="26" name="TextBox 25"/>
+          <p:cNvPr id="25" name="TextBox 24"/>
           <p:cNvSpPr txBox="1"/>
           <p:nvPr/>
         </p:nvSpPr>
@@ -11281,14 +11295,27 @@
               </a:defRPr>
             </a:pPr>
             <a:r>
-              <a:t>DTS Dual Temperature Switch</a:t>
-            </a:r>
-          </a:p>
-        </p:txBody>
-      </p:sp>
-      <p:sp>
-        <p:nvSpPr>
-          <p:cNvPr id="27" name="Rectangle 26"/>
+              <a:t>Callout Number 8</a:t>
+            </a:r>
+          </a:p>
+          <a:p>
+            <a:pPr algn="ctr">
+              <a:defRPr sz="700">
+                <a:solidFill>
+                  <a:srgbClr val="5F646E"/>
+                </a:solidFill>
+                <a:latin typeface="Arial"/>
+              </a:defRPr>
+            </a:pPr>
+            <a:r>
+              <a:t>8</a:t>
+            </a:r>
+          </a:p>
+        </p:txBody>
+      </p:sp>
+      <p:sp>
+        <p:nvSpPr>
+          <p:cNvPr id="26" name="Rectangle 25"/>
           <p:cNvSpPr/>
           <p:nvPr/>
         </p:nvSpPr>
@@ -11333,7 +11360,7 @@
       </p:sp>
       <p:sp>
         <p:nvSpPr>
-          <p:cNvPr id="28" name="TextBox 27"/>
+          <p:cNvPr id="27" name="TextBox 26"/>
           <p:cNvSpPr txBox="1"/>
           <p:nvPr/>
         </p:nvSpPr>
@@ -11359,14 +11386,27 @@
               </a:defRPr>
             </a:pPr>
             <a:r>
-              <a:t>EA Entrapment Horn/Strobe</a:t>
-            </a:r>
-          </a:p>
-        </p:txBody>
-      </p:sp>
-      <p:sp>
-        <p:nvSpPr>
-          <p:cNvPr id="29" name="Rectangle 28"/>
+              <a:t>Callout Number 9</a:t>
+            </a:r>
+          </a:p>
+          <a:p>
+            <a:pPr algn="ctr">
+              <a:defRPr sz="700">
+                <a:solidFill>
+                  <a:srgbClr val="5F646E"/>
+                </a:solidFill>
+                <a:latin typeface="Arial"/>
+              </a:defRPr>
+            </a:pPr>
+            <a:r>
+              <a:t>9</a:t>
+            </a:r>
+          </a:p>
+        </p:txBody>
+      </p:sp>
+      <p:sp>
+        <p:nvSpPr>
+          <p:cNvPr id="28" name="Rectangle 27"/>
           <p:cNvSpPr/>
           <p:nvPr/>
         </p:nvSpPr>
@@ -11411,7 +11451,7 @@
       </p:sp>
       <p:sp>
         <p:nvSpPr>
-          <p:cNvPr id="30" name="TextBox 29"/>
+          <p:cNvPr id="29" name="TextBox 28"/>
           <p:cNvSpPr txBox="1"/>
           <p:nvPr/>
         </p:nvSpPr>
@@ -11437,14 +11477,14 @@
               </a:defRPr>
             </a:pPr>
             <a:r>
-              <a:t>Electric Defrost Marker</a:t>
-            </a:r>
-          </a:p>
-        </p:txBody>
-      </p:sp>
-      <p:sp>
-        <p:nvSpPr>
-          <p:cNvPr id="31" name="Rectangle 30"/>
+              <a:t>DA Door Open Horn/Strobe</a:t>
+            </a:r>
+          </a:p>
+        </p:txBody>
+      </p:sp>
+      <p:sp>
+        <p:nvSpPr>
+          <p:cNvPr id="30" name="Rectangle 29"/>
           <p:cNvSpPr/>
           <p:nvPr/>
         </p:nvSpPr>
@@ -11489,7 +11529,7 @@
       </p:sp>
       <p:sp>
         <p:nvSpPr>
-          <p:cNvPr id="32" name="TextBox 31"/>
+          <p:cNvPr id="31" name="TextBox 30"/>
           <p:cNvSpPr txBox="1"/>
           <p:nvPr/>
         </p:nvSpPr>
@@ -11515,14 +11555,27 @@
               </a:defRPr>
             </a:pPr>
             <a:r>
-              <a:t>ES Entrapment Switch</a:t>
-            </a:r>
-          </a:p>
-        </p:txBody>
-      </p:sp>
-      <p:sp>
-        <p:nvSpPr>
-          <p:cNvPr id="33" name="Rectangle 32"/>
+              <a:t>Dimming Zone Marker</a:t>
+            </a:r>
+          </a:p>
+          <a:p>
+            <a:pPr algn="ctr">
+              <a:defRPr sz="700">
+                <a:solidFill>
+                  <a:srgbClr val="5F646E"/>
+                </a:solidFill>
+                <a:latin typeface="Arial"/>
+              </a:defRPr>
+            </a:pPr>
+            <a:r>
+              <a:t>DZ</a:t>
+            </a:r>
+          </a:p>
+        </p:txBody>
+      </p:sp>
+      <p:sp>
+        <p:nvSpPr>
+          <p:cNvPr id="32" name="Rectangle 31"/>
           <p:cNvSpPr/>
           <p:nvPr/>
         </p:nvSpPr>
@@ -11565,6 +11618,30 @@
           </a:p>
         </p:txBody>
       </p:sp>
+      <p:pic>
+        <p:nvPicPr>
+          <p:cNvPr id="33" name="S360_COMPONENT_ID=generic-din-rail|VARIANT=edge" descr="generic-din-rail__lineart.png"/>
+          <p:cNvPicPr>
+            <a:picLocks noChangeAspect="1"/>
+          </p:cNvPicPr>
+          <p:nvPr/>
+        </p:nvPicPr>
+        <p:blipFill>
+          <a:blip r:embed="rId2"/>
+          <a:stretch>
+            <a:fillRect/>
+          </a:stretch>
+        </p:blipFill>
+        <p:spPr>
+          <a:xfrm>
+            <a:off x="13413105" y="7743825"/>
+            <a:ext cx="514350" cy="514350"/>
+          </a:xfrm>
+          <a:prstGeom prst="rect">
+            <a:avLst/>
+          </a:prstGeom>
+        </p:spPr>
+      </p:pic>
       <p:sp>
         <p:nvSpPr>
           <p:cNvPr id="34" name="TextBox 33"/>
@@ -11593,7 +11670,7 @@
               </a:defRPr>
             </a:pPr>
             <a:r>
-              <a:t>HELP TRAPPED / PERSONA ATRAPADA Sign</a:t>
+              <a:t>DIN Rail</a:t>
             </a:r>
           </a:p>
         </p:txBody>
@@ -11768,20 +11845,7 @@
               </a:defRPr>
             </a:pPr>
             <a:r>
-              <a:t>HELP TRAPPED Symbol</a:t>
-            </a:r>
-          </a:p>
-          <a:p>
-            <a:pPr algn="ctr">
-              <a:defRPr sz="700">
-                <a:solidFill>
-                  <a:srgbClr val="5F646E"/>
-                </a:solidFill>
-                <a:latin typeface="Arial"/>
-              </a:defRPr>
-            </a:pPr>
-            <a:r>
-              <a:t>HELP TRAPPED</a:t>
+              <a:t>DS Defrost Sensor</a:t>
             </a:r>
           </a:p>
         </p:txBody>
@@ -11859,20 +11923,7 @@
               </a:defRPr>
             </a:pPr>
             <a:r>
-              <a:t>High-Temperature BBQ Sensor Callout</a:t>
-            </a:r>
-          </a:p>
-          <a:p>
-            <a:pPr algn="ctr">
-              <a:defRPr sz="700">
-                <a:solidFill>
-                  <a:srgbClr val="5F646E"/>
-                </a:solidFill>
-                <a:latin typeface="Arial"/>
-              </a:defRPr>
-            </a:pPr>
-            <a:r>
-              <a:t>12</a:t>
+              <a:t>DTS Dual Temperature Switch</a:t>
             </a:r>
           </a:p>
         </p:txBody>
@@ -11950,20 +12001,7 @@
               </a:defRPr>
             </a:pPr>
             <a:r>
-              <a:t>High-Temperature BBQ Sensor Callout</a:t>
-            </a:r>
-          </a:p>
-          <a:p>
-            <a:pPr algn="ctr">
-              <a:defRPr sz="700">
-                <a:solidFill>
-                  <a:srgbClr val="5F646E"/>
-                </a:solidFill>
-                <a:latin typeface="Arial"/>
-              </a:defRPr>
-            </a:pPr>
-            <a:r>
-              <a:t>12</a:t>
+              <a:t>EA Entrapment Horn/Strobe</a:t>
             </a:r>
           </a:p>
         </p:txBody>
@@ -12041,7 +12079,7 @@
               </a:defRPr>
             </a:pPr>
             <a:r>
-              <a:t>HS Horn Silencer Button</a:t>
+              <a:t>Electric Defrost Marker</a:t>
             </a:r>
           </a:p>
         </p:txBody>
@@ -12119,20 +12157,7 @@
               </a:defRPr>
             </a:pPr>
             <a:r>
-              <a:t>IDF Network Marker</a:t>
-            </a:r>
-          </a:p>
-          <a:p>
-            <a:pPr algn="ctr">
-              <a:defRPr sz="700">
-                <a:solidFill>
-                  <a:srgbClr val="5F646E"/>
-                </a:solidFill>
-                <a:latin typeface="Arial"/>
-              </a:defRPr>
-            </a:pPr>
-            <a:r>
-              <a:t>IDF</a:t>
+              <a:t>ES Entrapment Switch</a:t>
             </a:r>
           </a:p>
         </p:txBody>
@@ -12210,20 +12235,7 @@
               </a:defRPr>
             </a:pPr>
             <a:r>
-              <a:t>LCP Location Callout</a:t>
-            </a:r>
-          </a:p>
-          <a:p>
-            <a:pPr algn="ctr">
-              <a:defRPr sz="700">
-                <a:solidFill>
-                  <a:srgbClr val="5F646E"/>
-                </a:solidFill>
-                <a:latin typeface="Arial"/>
-              </a:defRPr>
-            </a:pPr>
-            <a:r>
-              <a:t>4</a:t>
+              <a:t>HELP TRAPPED / PERSONA ATRAPADA Sign</a:t>
             </a:r>
           </a:p>
         </p:txBody>
@@ -12301,7 +12313,7 @@
               </a:defRPr>
             </a:pPr>
             <a:r>
-              <a:t>LCP Location Callout</a:t>
+              <a:t>HELP TRAPPED Symbol</a:t>
             </a:r>
           </a:p>
           <a:p>
@@ -12314,7 +12326,7 @@
               </a:defRPr>
             </a:pPr>
             <a:r>
-              <a:t>4</a:t>
+              <a:t>HELP TRAPPED</a:t>
             </a:r>
           </a:p>
         </p:txBody>
@@ -12392,20 +12404,7 @@
               </a:defRPr>
             </a:pPr>
             <a:r>
-              <a:t>LCP Panel Marker</a:t>
-            </a:r>
-          </a:p>
-          <a:p>
-            <a:pPr algn="ctr">
-              <a:defRPr sz="700">
-                <a:solidFill>
-                  <a:srgbClr val="5F646E"/>
-                </a:solidFill>
-                <a:latin typeface="Arial"/>
-              </a:defRPr>
-            </a:pPr>
-            <a:r>
-              <a:t>LCP</a:t>
+              <a:t>HS Horn Silencer Button</a:t>
             </a:r>
           </a:p>
         </p:txBody>
@@ -12483,7 +12482,20 @@
               </a:defRPr>
             </a:pPr>
             <a:r>
-              <a:t>LI Leak Indicator Horn/Strobe</a:t>
+              <a:t>IDF Network Marker</a:t>
+            </a:r>
+          </a:p>
+          <a:p>
+            <a:pPr algn="ctr">
+              <a:defRPr sz="700">
+                <a:solidFill>
+                  <a:srgbClr val="5F646E"/>
+                </a:solidFill>
+                <a:latin typeface="Arial"/>
+              </a:defRPr>
+            </a:pPr>
+            <a:r>
+              <a:t>IDF</a:t>
             </a:r>
           </a:p>
         </p:txBody>
@@ -12561,7 +12573,20 @@
               </a:defRPr>
             </a:pPr>
             <a:r>
-              <a:t>Liquid Line Solenoid Marker</a:t>
+              <a:t>LCP Panel Marker</a:t>
+            </a:r>
+          </a:p>
+          <a:p>
+            <a:pPr algn="ctr">
+              <a:defRPr sz="700">
+                <a:solidFill>
+                  <a:srgbClr val="5F646E"/>
+                </a:solidFill>
+                <a:latin typeface="Arial"/>
+              </a:defRPr>
+            </a:pPr>
+            <a:r>
+              <a:t>LCP</a:t>
             </a:r>
           </a:p>
         </p:txBody>
@@ -12639,7 +12664,7 @@
               </a:defRPr>
             </a:pPr>
             <a:r>
-              <a:t>LS Leak Sensor</a:t>
+              <a:t>LI Leak Indicator Horn/Strobe</a:t>
             </a:r>
           </a:p>
         </p:txBody>
@@ -12717,20 +12742,7 @@
               </a:defRPr>
             </a:pPr>
             <a:r>
-              <a:t>LT Light Level / OAT Sensor</a:t>
-            </a:r>
-          </a:p>
-          <a:p>
-            <a:pPr algn="ctr">
-              <a:defRPr sz="700">
-                <a:solidFill>
-                  <a:srgbClr val="5F646E"/>
-                </a:solidFill>
-                <a:latin typeface="Arial"/>
-              </a:defRPr>
-            </a:pPr>
-            <a:r>
-              <a:t>LT</a:t>
+              <a:t>Liquid Line Solenoid Marker</a:t>
             </a:r>
           </a:p>
         </p:txBody>
@@ -12808,7 +12820,7 @@
               </a:defRPr>
             </a:pPr>
             <a:r>
-              <a:t>MDF Server Rack Marker</a:t>
+              <a:t>LS Leak Sensor</a:t>
             </a:r>
           </a:p>
         </p:txBody>
@@ -12886,7 +12898,7 @@
               </a:defRPr>
             </a:pPr>
             <a:r>
-              <a:t>OAT Outdoor Air Temp Sensor</a:t>
+              <a:t>LT Light Level / OAT Sensor</a:t>
             </a:r>
           </a:p>
           <a:p>
@@ -12899,7 +12911,7 @@
               </a:defRPr>
             </a:pPr>
             <a:r>
-              <a:t>OAT</a:t>
+              <a:t>LT</a:t>
             </a:r>
           </a:p>
         </p:txBody>
@@ -12977,20 +12989,7 @@
               </a:defRPr>
             </a:pPr>
             <a:r>
-              <a:t>Orbit TouchXL Location Callout</a:t>
-            </a:r>
-          </a:p>
-          <a:p>
-            <a:pPr algn="ctr">
-              <a:defRPr sz="700">
-                <a:solidFill>
-                  <a:srgbClr val="5F646E"/>
-                </a:solidFill>
-                <a:latin typeface="Arial"/>
-              </a:defRPr>
-            </a:pPr>
-            <a:r>
-              <a:t>7</a:t>
+              <a:t>MDF Server Rack Marker</a:t>
             </a:r>
           </a:p>
         </p:txBody>
@@ -13165,7 +13164,7 @@
               </a:defRPr>
             </a:pPr>
             <a:r>
-              <a:t>Orbit TouchXL Location Callout</a:t>
+              <a:t>OAT Outdoor Air Temp Sensor</a:t>
             </a:r>
           </a:p>
           <a:p>
@@ -13178,7 +13177,7 @@
               </a:defRPr>
             </a:pPr>
             <a:r>
-              <a:t>7</a:t>
+              <a:t>OAT</a:t>
             </a:r>
           </a:p>
         </p:txBody>
@@ -13334,7 +13333,7 @@
               </a:defRPr>
             </a:pPr>
             <a:r>
-              <a:t>Pharmacy Temperature Probe Callout</a:t>
+              <a:t>PM Power Monitor Marker</a:t>
             </a:r>
           </a:p>
           <a:p>
@@ -13347,7 +13346,7 @@
               </a:defRPr>
             </a:pPr>
             <a:r>
-              <a:t>10</a:t>
+              <a:t>PM</a:t>
             </a:r>
           </a:p>
         </p:txBody>
@@ -13425,20 +13424,7 @@
               </a:defRPr>
             </a:pPr>
             <a:r>
-              <a:t>Pharmacy Temperature Probe Callout</a:t>
-            </a:r>
-          </a:p>
-          <a:p>
-            <a:pPr algn="ctr">
-              <a:defRPr sz="700">
-                <a:solidFill>
-                  <a:srgbClr val="5F646E"/>
-                </a:solidFill>
-                <a:latin typeface="Arial"/>
-              </a:defRPr>
-            </a:pPr>
-            <a:r>
-              <a:t>10</a:t>
+              <a:t>RDM IDF Marker</a:t>
             </a:r>
           </a:p>
         </p:txBody>
@@ -13516,7 +13502,7 @@
               </a:defRPr>
             </a:pPr>
             <a:r>
-              <a:t>PM Power Monitor Marker</a:t>
+              <a:t>Signage Legend - Safety / Trapped / Leak</a:t>
             </a:r>
           </a:p>
           <a:p>
@@ -13529,7 +13515,7 @@
               </a:defRPr>
             </a:pPr>
             <a:r>
-              <a:t>PM</a:t>
+              <a:t>Signage Legend</a:t>
             </a:r>
           </a:p>
         </p:txBody>
@@ -13607,20 +13593,7 @@
               </a:defRPr>
             </a:pPr>
             <a:r>
-              <a:t>Power Monitor Location Callout</a:t>
-            </a:r>
-          </a:p>
-          <a:p>
-            <a:pPr algn="ctr">
-              <a:defRPr sz="700">
-                <a:solidFill>
-                  <a:srgbClr val="5F646E"/>
-                </a:solidFill>
-                <a:latin typeface="Arial"/>
-              </a:defRPr>
-            </a:pPr>
-            <a:r>
-              <a:t>6</a:t>
+              <a:t>Signage Legend Safety</a:t>
             </a:r>
           </a:p>
         </p:txBody>
@@ -13670,9 +13643,33 @@
           </a:p>
         </p:txBody>
       </p:sp>
-      <p:sp>
-        <p:nvSpPr>
-          <p:cNvPr id="17" name="TextBox 16"/>
+      <p:pic>
+        <p:nvPicPr>
+          <p:cNvPr id="17" name="S360_COMPONENT_ID=signage_safety_51011bbb37|VARIANT=edge" descr="signage_legend_safety_trapped_leak_help.png"/>
+          <p:cNvPicPr>
+            <a:picLocks noChangeAspect="1"/>
+          </p:cNvPicPr>
+          <p:nvPr/>
+        </p:nvPicPr>
+        <p:blipFill>
+          <a:blip r:embed="rId2"/>
+          <a:stretch>
+            <a:fillRect/>
+          </a:stretch>
+        </p:blipFill>
+        <p:spPr>
+          <a:xfrm>
+            <a:off x="3434333" y="4080510"/>
+            <a:ext cx="2476500" cy="1714500"/>
+          </a:xfrm>
+          <a:prstGeom prst="rect">
+            <a:avLst/>
+          </a:prstGeom>
+        </p:spPr>
+      </p:pic>
+      <p:sp>
+        <p:nvSpPr>
+          <p:cNvPr id="18" name="TextBox 17"/>
           <p:cNvSpPr txBox="1"/>
           <p:nvPr/>
         </p:nvSpPr>
@@ -13698,27 +13695,14 @@
               </a:defRPr>
             </a:pPr>
             <a:r>
-              <a:t>Power Monitor Location Callout</a:t>
-            </a:r>
-          </a:p>
-          <a:p>
-            <a:pPr algn="ctr">
-              <a:defRPr sz="700">
-                <a:solidFill>
-                  <a:srgbClr val="5F646E"/>
-                </a:solidFill>
-                <a:latin typeface="Arial"/>
-              </a:defRPr>
-            </a:pPr>
-            <a:r>
-              <a:t>6</a:t>
-            </a:r>
-          </a:p>
-        </p:txBody>
-      </p:sp>
-      <p:sp>
-        <p:nvSpPr>
-          <p:cNvPr id="18" name="Rectangle 17"/>
+              <a:t>Signage Legend Safety Trapped Leak Help</a:t>
+            </a:r>
+          </a:p>
+        </p:txBody>
+      </p:sp>
+      <p:sp>
+        <p:nvSpPr>
+          <p:cNvPr id="19" name="Rectangle 18"/>
           <p:cNvSpPr/>
           <p:nvPr/>
         </p:nvSpPr>
@@ -13763,7 +13747,7 @@
       </p:sp>
       <p:sp>
         <p:nvSpPr>
-          <p:cNvPr id="19" name="TextBox 18"/>
+          <p:cNvPr id="20" name="TextBox 19"/>
           <p:cNvSpPr txBox="1"/>
           <p:nvPr/>
         </p:nvSpPr>
@@ -13789,7 +13773,7 @@
               </a:defRPr>
             </a:pPr>
             <a:r>
-              <a:t>RDM IDF Location Callout</a:t>
+              <a:t>Signage Legend Strip</a:t>
             </a:r>
           </a:p>
           <a:p>
@@ -13802,14 +13786,14 @@
               </a:defRPr>
             </a:pPr>
             <a:r>
-              <a:t>2</a:t>
-            </a:r>
-          </a:p>
-        </p:txBody>
-      </p:sp>
-      <p:sp>
-        <p:nvSpPr>
-          <p:cNvPr id="20" name="Rectangle 19"/>
+              <a:t>Signage Legend</a:t>
+            </a:r>
+          </a:p>
+        </p:txBody>
+      </p:sp>
+      <p:sp>
+        <p:nvSpPr>
+          <p:cNvPr id="21" name="Rectangle 20"/>
           <p:cNvSpPr/>
           <p:nvPr/>
         </p:nvSpPr>
@@ -13854,7 +13838,7 @@
       </p:sp>
       <p:sp>
         <p:nvSpPr>
-          <p:cNvPr id="21" name="TextBox 20"/>
+          <p:cNvPr id="22" name="TextBox 21"/>
           <p:cNvSpPr txBox="1"/>
           <p:nvPr/>
         </p:nvSpPr>
@@ -13880,27 +13864,14 @@
               </a:defRPr>
             </a:pPr>
             <a:r>
-              <a:t>RDM IDF Location Callout</a:t>
-            </a:r>
-          </a:p>
-          <a:p>
-            <a:pPr algn="ctr">
-              <a:defRPr sz="700">
-                <a:solidFill>
-                  <a:srgbClr val="5F646E"/>
-                </a:solidFill>
-                <a:latin typeface="Arial"/>
-              </a:defRPr>
-            </a:pPr>
-            <a:r>
-              <a:t>2</a:t>
-            </a:r>
-          </a:p>
-        </p:txBody>
-      </p:sp>
-      <p:sp>
-        <p:nvSpPr>
-          <p:cNvPr id="22" name="Rectangle 21"/>
+              <a:t>Sym Pm Power Monitor Marker</a:t>
+            </a:r>
+          </a:p>
+        </p:txBody>
+      </p:sp>
+      <p:sp>
+        <p:nvSpPr>
+          <p:cNvPr id="23" name="Rectangle 22"/>
           <p:cNvSpPr/>
           <p:nvPr/>
         </p:nvSpPr>
@@ -13945,7 +13916,7 @@
       </p:sp>
       <p:sp>
         <p:nvSpPr>
-          <p:cNvPr id="23" name="TextBox 22"/>
+          <p:cNvPr id="24" name="TextBox 23"/>
           <p:cNvSpPr txBox="1"/>
           <p:nvPr/>
         </p:nvSpPr>
@@ -13971,14 +13942,14 @@
               </a:defRPr>
             </a:pPr>
             <a:r>
-              <a:t>RDM IDF Marker</a:t>
-            </a:r>
-          </a:p>
-        </p:txBody>
-      </p:sp>
-      <p:sp>
-        <p:nvSpPr>
-          <p:cNvPr id="24" name="Rectangle 23"/>
+              <a:t>Sym T Temp Input</a:t>
+            </a:r>
+          </a:p>
+        </p:txBody>
+      </p:sp>
+      <p:sp>
+        <p:nvSpPr>
+          <p:cNvPr id="25" name="Rectangle 24"/>
           <p:cNvSpPr/>
           <p:nvPr/>
         </p:nvSpPr>
@@ -14023,7 +13994,7 @@
       </p:sp>
       <p:sp>
         <p:nvSpPr>
-          <p:cNvPr id="25" name="TextBox 24"/>
+          <p:cNvPr id="26" name="TextBox 25"/>
           <p:cNvSpPr txBox="1"/>
           <p:nvPr/>
         </p:nvSpPr>
@@ -14049,7 +14020,7 @@
               </a:defRPr>
             </a:pPr>
             <a:r>
-              <a:t>Red Alarm Strobe Callout</a:t>
+              <a:t>T Temperature Input</a:t>
             </a:r>
           </a:p>
           <a:p>
@@ -14062,14 +14033,14 @@
               </a:defRPr>
             </a:pPr>
             <a:r>
-              <a:t>9</a:t>
-            </a:r>
-          </a:p>
-        </p:txBody>
-      </p:sp>
-      <p:sp>
-        <p:nvSpPr>
-          <p:cNvPr id="26" name="Rectangle 25"/>
+              <a:t>T</a:t>
+            </a:r>
+          </a:p>
+        </p:txBody>
+      </p:sp>
+      <p:sp>
+        <p:nvSpPr>
+          <p:cNvPr id="27" name="Rectangle 26"/>
           <p:cNvSpPr/>
           <p:nvPr/>
         </p:nvSpPr>
@@ -14114,7 +14085,7 @@
       </p:sp>
       <p:sp>
         <p:nvSpPr>
-          <p:cNvPr id="27" name="TextBox 26"/>
+          <p:cNvPr id="28" name="TextBox 27"/>
           <p:cNvSpPr txBox="1"/>
           <p:nvPr/>
         </p:nvSpPr>
@@ -14140,27 +14111,14 @@
               </a:defRPr>
             </a:pPr>
             <a:r>
-              <a:t>Red Alarm Strobe Callout</a:t>
-            </a:r>
-          </a:p>
-          <a:p>
-            <a:pPr algn="ctr">
-              <a:defRPr sz="700">
-                <a:solidFill>
-                  <a:srgbClr val="5F646E"/>
-                </a:solidFill>
-                <a:latin typeface="Arial"/>
-              </a:defRPr>
-            </a:pPr>
-            <a:r>
-              <a:t>9</a:t>
-            </a:r>
-          </a:p>
-        </p:txBody>
-      </p:sp>
-      <p:sp>
-        <p:nvSpPr>
-          <p:cNvPr id="28" name="Rectangle 27"/>
+              <a:t>TS Temperature Sensor</a:t>
+            </a:r>
+          </a:p>
+        </p:txBody>
+      </p:sp>
+      <p:sp>
+        <p:nvSpPr>
+          <p:cNvPr id="29" name="Rectangle 28"/>
           <p:cNvSpPr/>
           <p:nvPr/>
         </p:nvSpPr>
@@ -14205,7 +14163,7 @@
       </p:sp>
       <p:sp>
         <p:nvSpPr>
-          <p:cNvPr id="29" name="TextBox 28"/>
+          <p:cNvPr id="30" name="TextBox 29"/>
           <p:cNvSpPr txBox="1"/>
           <p:nvPr/>
         </p:nvSpPr>
@@ -14231,27 +14189,14 @@
               </a:defRPr>
             </a:pPr>
             <a:r>
-              <a:t>Refrigeration Temperature Sensor Callout</a:t>
-            </a:r>
-          </a:p>
-          <a:p>
-            <a:pPr algn="ctr">
-              <a:defRPr sz="700">
-                <a:solidFill>
-                  <a:srgbClr val="5F646E"/>
-                </a:solidFill>
-                <a:latin typeface="Arial"/>
-              </a:defRPr>
-            </a:pPr>
-            <a:r>
-              <a:t>5</a:t>
-            </a:r>
-          </a:p>
-        </p:txBody>
-      </p:sp>
-      <p:sp>
-        <p:nvSpPr>
-          <p:cNvPr id="30" name="Rectangle 29"/>
+              <a:t>When Lit Refrigerant Leak — Do Not Enter Sign</a:t>
+            </a:r>
+          </a:p>
+        </p:txBody>
+      </p:sp>
+      <p:sp>
+        <p:nvSpPr>
+          <p:cNvPr id="31" name="Rectangle 30"/>
           <p:cNvSpPr/>
           <p:nvPr/>
         </p:nvSpPr>
@@ -14296,7 +14241,7 @@
       </p:sp>
       <p:sp>
         <p:nvSpPr>
-          <p:cNvPr id="31" name="TextBox 30"/>
+          <p:cNvPr id="32" name="TextBox 31"/>
           <p:cNvSpPr txBox="1"/>
           <p:nvPr/>
         </p:nvSpPr>
@@ -14322,7 +14267,7 @@
               </a:defRPr>
             </a:pPr>
             <a:r>
-              <a:t>Refrigeration Temperature Sensor Callout</a:t>
+              <a:t>WICP Panel Marker</a:t>
             </a:r>
           </a:p>
           <a:p>
@@ -14335,98 +14280,7 @@
               </a:defRPr>
             </a:pPr>
             <a:r>
-              <a:t>5</a:t>
-            </a:r>
-          </a:p>
-        </p:txBody>
-      </p:sp>
-      <p:sp>
-        <p:nvSpPr>
-          <p:cNvPr id="32" name="Rectangle 31"/>
-          <p:cNvSpPr/>
-          <p:nvPr/>
-        </p:nvSpPr>
-        <p:spPr>
-          <a:xfrm>
-            <a:off x="12225528" y="6720840"/>
-            <a:ext cx="2889503" cy="2935224"/>
-          </a:xfrm>
-          <a:prstGeom prst="rect">
-            <a:avLst/>
-          </a:prstGeom>
-          <a:solidFill>
-            <a:srgbClr val="FAFBFD"/>
-          </a:solidFill>
-          <a:ln w="8890">
-            <a:solidFill>
-              <a:srgbClr val="D7DCE5"/>
-            </a:solidFill>
-          </a:ln>
-        </p:spPr>
-        <p:style>
-          <a:lnRef idx="1">
-            <a:schemeClr val="accent1"/>
-          </a:lnRef>
-          <a:fillRef idx="3">
-            <a:schemeClr val="accent1"/>
-          </a:fillRef>
-          <a:effectRef idx="2">
-            <a:schemeClr val="accent1"/>
-          </a:effectRef>
-          <a:fontRef idx="minor">
-            <a:schemeClr val="lt1"/>
-          </a:fontRef>
-        </p:style>
-        <p:txBody>
-          <a:bodyPr rtlCol="0" anchor="ctr"/>
-          <a:lstStyle/>
-          <a:p>
-            <a:pPr algn="ctr"/>
-          </a:p>
-        </p:txBody>
-      </p:sp>
-      <p:sp>
-        <p:nvSpPr>
-          <p:cNvPr id="33" name="TextBox 32"/>
-          <p:cNvSpPr txBox="1"/>
-          <p:nvPr/>
-        </p:nvSpPr>
-        <p:spPr>
-          <a:xfrm>
-            <a:off x="12353544" y="9034272"/>
-            <a:ext cx="2633472" cy="502920"/>
-          </a:xfrm>
-          <a:prstGeom prst="rect">
-            <a:avLst/>
-          </a:prstGeom>
-          <a:noFill/>
-        </p:spPr>
-        <p:txBody>
-          <a:bodyPr wrap="none">
-            <a:spAutoFit/>
-          </a:bodyPr>
-          <a:lstStyle/>
-          <a:p>
-            <a:pPr algn="ctr">
-              <a:defRPr sz="900" b="1">
-                <a:latin typeface="Arial"/>
-              </a:defRPr>
-            </a:pPr>
-            <a:r>
-              <a:t>Signage Legend - Safety / Trapped / Leak</a:t>
-            </a:r>
-          </a:p>
-          <a:p>
-            <a:pPr algn="ctr">
-              <a:defRPr sz="700">
-                <a:solidFill>
-                  <a:srgbClr val="5F646E"/>
-                </a:solidFill>
-                <a:latin typeface="Arial"/>
-              </a:defRPr>
-            </a:pPr>
-            <a:r>
-              <a:t>Signage Legend</a:t>
+              <a:t>WICP</a:t>
             </a:r>
           </a:p>
         </p:txBody>
@@ -16017,1050 +15871,6 @@
 </p:sld>
 </file>
 
-<file path=ppt/slides/slide20.xml><?xml version="1.0" encoding="utf-8"?>
-<p:sld xmlns:a="http://schemas.openxmlformats.org/drawingml/2006/main" xmlns:p="http://schemas.openxmlformats.org/presentationml/2006/main" xmlns:r="http://schemas.openxmlformats.org/officeDocument/2006/relationships">
-  <p:cSld>
-    <p:spTree>
-      <p:nvGrpSpPr>
-        <p:cNvPr id="1" name=""/>
-        <p:cNvGrpSpPr/>
-        <p:nvPr/>
-      </p:nvGrpSpPr>
-      <p:grpSpPr/>
-      <p:sp>
-        <p:nvSpPr>
-          <p:cNvPr id="2" name="Rectangle 1"/>
-          <p:cNvSpPr/>
-          <p:nvPr/>
-        </p:nvSpPr>
-        <p:spPr>
-          <a:xfrm>
-            <a:off x="0" y="0"/>
-            <a:ext cx="15544800" cy="457200"/>
-          </a:xfrm>
-          <a:prstGeom prst="rect">
-            <a:avLst/>
-          </a:prstGeom>
-          <a:solidFill>
-            <a:srgbClr val="0C1730"/>
-          </a:solidFill>
-          <a:ln>
-            <a:noFill/>
-          </a:ln>
-        </p:spPr>
-        <p:style>
-          <a:lnRef idx="1">
-            <a:schemeClr val="accent1"/>
-          </a:lnRef>
-          <a:fillRef idx="3">
-            <a:schemeClr val="accent1"/>
-          </a:fillRef>
-          <a:effectRef idx="2">
-            <a:schemeClr val="accent1"/>
-          </a:effectRef>
-          <a:fontRef idx="minor">
-            <a:schemeClr val="lt1"/>
-          </a:fontRef>
-        </p:style>
-        <p:txBody>
-          <a:bodyPr rtlCol="0" anchor="ctr"/>
-          <a:lstStyle/>
-          <a:p>
-            <a:pPr algn="ctr"/>
-          </a:p>
-        </p:txBody>
-      </p:sp>
-      <p:sp>
-        <p:nvSpPr>
-          <p:cNvPr id="3" name="TextBox 2"/>
-          <p:cNvSpPr txBox="1"/>
-          <p:nvPr/>
-        </p:nvSpPr>
-        <p:spPr>
-          <a:xfrm>
-            <a:off x="274320" y="73152"/>
-            <a:ext cx="14996159" cy="274320"/>
-          </a:xfrm>
-          <a:prstGeom prst="rect">
-            <a:avLst/>
-          </a:prstGeom>
-          <a:noFill/>
-        </p:spPr>
-        <p:txBody>
-          <a:bodyPr wrap="none">
-            <a:spAutoFit/>
-          </a:bodyPr>
-          <a:lstStyle/>
-          <a:p>
-            <a:pPr algn="ctr">
-              <a:defRPr sz="1600" b="1">
-                <a:solidFill>
-                  <a:srgbClr val="FFFFFF"/>
-                </a:solidFill>
-                <a:latin typeface="Arial"/>
-              </a:defRPr>
-            </a:pPr>
-            <a:r>
-              <a:t>Symbols Markers — Edge Components</a:t>
-            </a:r>
-          </a:p>
-        </p:txBody>
-      </p:sp>
-      <p:sp>
-        <p:nvSpPr>
-          <p:cNvPr id="4" name="Rectangle 3"/>
-          <p:cNvSpPr/>
-          <p:nvPr/>
-        </p:nvSpPr>
-        <p:spPr>
-          <a:xfrm>
-            <a:off x="228600" y="594360"/>
-            <a:ext cx="2889503" cy="2935224"/>
-          </a:xfrm>
-          <a:prstGeom prst="rect">
-            <a:avLst/>
-          </a:prstGeom>
-          <a:solidFill>
-            <a:srgbClr val="FAFBFD"/>
-          </a:solidFill>
-          <a:ln w="8890">
-            <a:solidFill>
-              <a:srgbClr val="D7DCE5"/>
-            </a:solidFill>
-          </a:ln>
-        </p:spPr>
-        <p:style>
-          <a:lnRef idx="1">
-            <a:schemeClr val="accent1"/>
-          </a:lnRef>
-          <a:fillRef idx="3">
-            <a:schemeClr val="accent1"/>
-          </a:fillRef>
-          <a:effectRef idx="2">
-            <a:schemeClr val="accent1"/>
-          </a:effectRef>
-          <a:fontRef idx="minor">
-            <a:schemeClr val="lt1"/>
-          </a:fontRef>
-        </p:style>
-        <p:txBody>
-          <a:bodyPr rtlCol="0" anchor="ctr"/>
-          <a:lstStyle/>
-          <a:p>
-            <a:pPr algn="ctr"/>
-          </a:p>
-        </p:txBody>
-      </p:sp>
-      <p:sp>
-        <p:nvSpPr>
-          <p:cNvPr id="5" name="TextBox 4"/>
-          <p:cNvSpPr txBox="1"/>
-          <p:nvPr/>
-        </p:nvSpPr>
-        <p:spPr>
-          <a:xfrm>
-            <a:off x="356616" y="2907792"/>
-            <a:ext cx="2633472" cy="502920"/>
-          </a:xfrm>
-          <a:prstGeom prst="rect">
-            <a:avLst/>
-          </a:prstGeom>
-          <a:noFill/>
-        </p:spPr>
-        <p:txBody>
-          <a:bodyPr wrap="none">
-            <a:spAutoFit/>
-          </a:bodyPr>
-          <a:lstStyle/>
-          <a:p>
-            <a:pPr algn="ctr">
-              <a:defRPr sz="900" b="1">
-                <a:latin typeface="Arial"/>
-              </a:defRPr>
-            </a:pPr>
-            <a:r>
-              <a:t>Signage Legend Safety</a:t>
-            </a:r>
-          </a:p>
-        </p:txBody>
-      </p:sp>
-      <p:sp>
-        <p:nvSpPr>
-          <p:cNvPr id="6" name="Rectangle 5"/>
-          <p:cNvSpPr/>
-          <p:nvPr/>
-        </p:nvSpPr>
-        <p:spPr>
-          <a:xfrm>
-            <a:off x="3227832" y="594360"/>
-            <a:ext cx="2889503" cy="2935224"/>
-          </a:xfrm>
-          <a:prstGeom prst="rect">
-            <a:avLst/>
-          </a:prstGeom>
-          <a:solidFill>
-            <a:srgbClr val="FAFBFD"/>
-          </a:solidFill>
-          <a:ln w="8890">
-            <a:solidFill>
-              <a:srgbClr val="D7DCE5"/>
-            </a:solidFill>
-          </a:ln>
-        </p:spPr>
-        <p:style>
-          <a:lnRef idx="1">
-            <a:schemeClr val="accent1"/>
-          </a:lnRef>
-          <a:fillRef idx="3">
-            <a:schemeClr val="accent1"/>
-          </a:fillRef>
-          <a:effectRef idx="2">
-            <a:schemeClr val="accent1"/>
-          </a:effectRef>
-          <a:fontRef idx="minor">
-            <a:schemeClr val="lt1"/>
-          </a:fontRef>
-        </p:style>
-        <p:txBody>
-          <a:bodyPr rtlCol="0" anchor="ctr"/>
-          <a:lstStyle/>
-          <a:p>
-            <a:pPr algn="ctr"/>
-          </a:p>
-        </p:txBody>
-      </p:sp>
-      <p:pic>
-        <p:nvPicPr>
-          <p:cNvPr id="7" name="S360_COMPONENT_ID=signage_safety_51011bbb37|VARIANT=edge" descr="signage_legend_safety_trapped_leak_help.png"/>
-          <p:cNvPicPr>
-            <a:picLocks noChangeAspect="1"/>
-          </p:cNvPicPr>
-          <p:nvPr/>
-        </p:nvPicPr>
-        <p:blipFill>
-          <a:blip r:embed="rId2"/>
-          <a:stretch>
-            <a:fillRect/>
-          </a:stretch>
-        </p:blipFill>
-        <p:spPr>
-          <a:xfrm>
-            <a:off x="3434333" y="1017269"/>
-            <a:ext cx="2476500" cy="1714500"/>
-          </a:xfrm>
-          <a:prstGeom prst="rect">
-            <a:avLst/>
-          </a:prstGeom>
-        </p:spPr>
-      </p:pic>
-      <p:sp>
-        <p:nvSpPr>
-          <p:cNvPr id="8" name="TextBox 7"/>
-          <p:cNvSpPr txBox="1"/>
-          <p:nvPr/>
-        </p:nvSpPr>
-        <p:spPr>
-          <a:xfrm>
-            <a:off x="3355848" y="2907792"/>
-            <a:ext cx="2633472" cy="502920"/>
-          </a:xfrm>
-          <a:prstGeom prst="rect">
-            <a:avLst/>
-          </a:prstGeom>
-          <a:noFill/>
-        </p:spPr>
-        <p:txBody>
-          <a:bodyPr wrap="none">
-            <a:spAutoFit/>
-          </a:bodyPr>
-          <a:lstStyle/>
-          <a:p>
-            <a:pPr algn="ctr">
-              <a:defRPr sz="900" b="1">
-                <a:latin typeface="Arial"/>
-              </a:defRPr>
-            </a:pPr>
-            <a:r>
-              <a:t>Signage Legend Safety Trapped Leak Help</a:t>
-            </a:r>
-          </a:p>
-        </p:txBody>
-      </p:sp>
-      <p:sp>
-        <p:nvSpPr>
-          <p:cNvPr id="9" name="Rectangle 8"/>
-          <p:cNvSpPr/>
-          <p:nvPr/>
-        </p:nvSpPr>
-        <p:spPr>
-          <a:xfrm>
-            <a:off x="6227064" y="594360"/>
-            <a:ext cx="2889503" cy="2935224"/>
-          </a:xfrm>
-          <a:prstGeom prst="rect">
-            <a:avLst/>
-          </a:prstGeom>
-          <a:solidFill>
-            <a:srgbClr val="FAFBFD"/>
-          </a:solidFill>
-          <a:ln w="8890">
-            <a:solidFill>
-              <a:srgbClr val="D7DCE5"/>
-            </a:solidFill>
-          </a:ln>
-        </p:spPr>
-        <p:style>
-          <a:lnRef idx="1">
-            <a:schemeClr val="accent1"/>
-          </a:lnRef>
-          <a:fillRef idx="3">
-            <a:schemeClr val="accent1"/>
-          </a:fillRef>
-          <a:effectRef idx="2">
-            <a:schemeClr val="accent1"/>
-          </a:effectRef>
-          <a:fontRef idx="minor">
-            <a:schemeClr val="lt1"/>
-          </a:fontRef>
-        </p:style>
-        <p:txBody>
-          <a:bodyPr rtlCol="0" anchor="ctr"/>
-          <a:lstStyle/>
-          <a:p>
-            <a:pPr algn="ctr"/>
-          </a:p>
-        </p:txBody>
-      </p:sp>
-      <p:sp>
-        <p:nvSpPr>
-          <p:cNvPr id="10" name="TextBox 9"/>
-          <p:cNvSpPr txBox="1"/>
-          <p:nvPr/>
-        </p:nvSpPr>
-        <p:spPr>
-          <a:xfrm>
-            <a:off x="6355079" y="2907792"/>
-            <a:ext cx="2633472" cy="502920"/>
-          </a:xfrm>
-          <a:prstGeom prst="rect">
-            <a:avLst/>
-          </a:prstGeom>
-          <a:noFill/>
-        </p:spPr>
-        <p:txBody>
-          <a:bodyPr wrap="none">
-            <a:spAutoFit/>
-          </a:bodyPr>
-          <a:lstStyle/>
-          <a:p>
-            <a:pPr algn="ctr">
-              <a:defRPr sz="900" b="1">
-                <a:latin typeface="Arial"/>
-              </a:defRPr>
-            </a:pPr>
-            <a:r>
-              <a:t>Signage Legend Strip</a:t>
-            </a:r>
-          </a:p>
-          <a:p>
-            <a:pPr algn="ctr">
-              <a:defRPr sz="700">
-                <a:solidFill>
-                  <a:srgbClr val="5F646E"/>
-                </a:solidFill>
-                <a:latin typeface="Arial"/>
-              </a:defRPr>
-            </a:pPr>
-            <a:r>
-              <a:t>Signage Legend</a:t>
-            </a:r>
-          </a:p>
-        </p:txBody>
-      </p:sp>
-      <p:sp>
-        <p:nvSpPr>
-          <p:cNvPr id="11" name="Rectangle 10"/>
-          <p:cNvSpPr/>
-          <p:nvPr/>
-        </p:nvSpPr>
-        <p:spPr>
-          <a:xfrm>
-            <a:off x="9226296" y="594360"/>
-            <a:ext cx="2889503" cy="2935224"/>
-          </a:xfrm>
-          <a:prstGeom prst="rect">
-            <a:avLst/>
-          </a:prstGeom>
-          <a:solidFill>
-            <a:srgbClr val="FAFBFD"/>
-          </a:solidFill>
-          <a:ln w="8890">
-            <a:solidFill>
-              <a:srgbClr val="D7DCE5"/>
-            </a:solidFill>
-          </a:ln>
-        </p:spPr>
-        <p:style>
-          <a:lnRef idx="1">
-            <a:schemeClr val="accent1"/>
-          </a:lnRef>
-          <a:fillRef idx="3">
-            <a:schemeClr val="accent1"/>
-          </a:fillRef>
-          <a:effectRef idx="2">
-            <a:schemeClr val="accent1"/>
-          </a:effectRef>
-          <a:fontRef idx="minor">
-            <a:schemeClr val="lt1"/>
-          </a:fontRef>
-        </p:style>
-        <p:txBody>
-          <a:bodyPr rtlCol="0" anchor="ctr"/>
-          <a:lstStyle/>
-          <a:p>
-            <a:pPr algn="ctr"/>
-          </a:p>
-        </p:txBody>
-      </p:sp>
-      <p:sp>
-        <p:nvSpPr>
-          <p:cNvPr id="12" name="TextBox 11"/>
-          <p:cNvSpPr txBox="1"/>
-          <p:nvPr/>
-        </p:nvSpPr>
-        <p:spPr>
-          <a:xfrm>
-            <a:off x="9354312" y="2907792"/>
-            <a:ext cx="2633472" cy="502920"/>
-          </a:xfrm>
-          <a:prstGeom prst="rect">
-            <a:avLst/>
-          </a:prstGeom>
-          <a:noFill/>
-        </p:spPr>
-        <p:txBody>
-          <a:bodyPr wrap="none">
-            <a:spAutoFit/>
-          </a:bodyPr>
-          <a:lstStyle/>
-          <a:p>
-            <a:pPr algn="ctr">
-              <a:defRPr sz="900" b="1">
-                <a:latin typeface="Arial"/>
-              </a:defRPr>
-            </a:pPr>
-            <a:r>
-              <a:t>Sym Pm Power Monitor Marker</a:t>
-            </a:r>
-          </a:p>
-        </p:txBody>
-      </p:sp>
-      <p:sp>
-        <p:nvSpPr>
-          <p:cNvPr id="13" name="Rectangle 12"/>
-          <p:cNvSpPr/>
-          <p:nvPr/>
-        </p:nvSpPr>
-        <p:spPr>
-          <a:xfrm>
-            <a:off x="12225528" y="594360"/>
-            <a:ext cx="2889503" cy="2935224"/>
-          </a:xfrm>
-          <a:prstGeom prst="rect">
-            <a:avLst/>
-          </a:prstGeom>
-          <a:solidFill>
-            <a:srgbClr val="FAFBFD"/>
-          </a:solidFill>
-          <a:ln w="8890">
-            <a:solidFill>
-              <a:srgbClr val="D7DCE5"/>
-            </a:solidFill>
-          </a:ln>
-        </p:spPr>
-        <p:style>
-          <a:lnRef idx="1">
-            <a:schemeClr val="accent1"/>
-          </a:lnRef>
-          <a:fillRef idx="3">
-            <a:schemeClr val="accent1"/>
-          </a:fillRef>
-          <a:effectRef idx="2">
-            <a:schemeClr val="accent1"/>
-          </a:effectRef>
-          <a:fontRef idx="minor">
-            <a:schemeClr val="lt1"/>
-          </a:fontRef>
-        </p:style>
-        <p:txBody>
-          <a:bodyPr rtlCol="0" anchor="ctr"/>
-          <a:lstStyle/>
-          <a:p>
-            <a:pPr algn="ctr"/>
-          </a:p>
-        </p:txBody>
-      </p:sp>
-      <p:sp>
-        <p:nvSpPr>
-          <p:cNvPr id="14" name="TextBox 13"/>
-          <p:cNvSpPr txBox="1"/>
-          <p:nvPr/>
-        </p:nvSpPr>
-        <p:spPr>
-          <a:xfrm>
-            <a:off x="12353544" y="2907792"/>
-            <a:ext cx="2633472" cy="502920"/>
-          </a:xfrm>
-          <a:prstGeom prst="rect">
-            <a:avLst/>
-          </a:prstGeom>
-          <a:noFill/>
-        </p:spPr>
-        <p:txBody>
-          <a:bodyPr wrap="none">
-            <a:spAutoFit/>
-          </a:bodyPr>
-          <a:lstStyle/>
-          <a:p>
-            <a:pPr algn="ctr">
-              <a:defRPr sz="900" b="1">
-                <a:latin typeface="Arial"/>
-              </a:defRPr>
-            </a:pPr>
-            <a:r>
-              <a:t>Sym T Temp Input</a:t>
-            </a:r>
-          </a:p>
-        </p:txBody>
-      </p:sp>
-      <p:sp>
-        <p:nvSpPr>
-          <p:cNvPr id="15" name="Rectangle 14"/>
-          <p:cNvSpPr/>
-          <p:nvPr/>
-        </p:nvSpPr>
-        <p:spPr>
-          <a:xfrm>
-            <a:off x="228600" y="3657600"/>
-            <a:ext cx="2889503" cy="2935224"/>
-          </a:xfrm>
-          <a:prstGeom prst="rect">
-            <a:avLst/>
-          </a:prstGeom>
-          <a:solidFill>
-            <a:srgbClr val="FAFBFD"/>
-          </a:solidFill>
-          <a:ln w="8890">
-            <a:solidFill>
-              <a:srgbClr val="D7DCE5"/>
-            </a:solidFill>
-          </a:ln>
-        </p:spPr>
-        <p:style>
-          <a:lnRef idx="1">
-            <a:schemeClr val="accent1"/>
-          </a:lnRef>
-          <a:fillRef idx="3">
-            <a:schemeClr val="accent1"/>
-          </a:fillRef>
-          <a:effectRef idx="2">
-            <a:schemeClr val="accent1"/>
-          </a:effectRef>
-          <a:fontRef idx="minor">
-            <a:schemeClr val="lt1"/>
-          </a:fontRef>
-        </p:style>
-        <p:txBody>
-          <a:bodyPr rtlCol="0" anchor="ctr"/>
-          <a:lstStyle/>
-          <a:p>
-            <a:pPr algn="ctr"/>
-          </a:p>
-        </p:txBody>
-      </p:sp>
-      <p:sp>
-        <p:nvSpPr>
-          <p:cNvPr id="16" name="TextBox 15"/>
-          <p:cNvSpPr txBox="1"/>
-          <p:nvPr/>
-        </p:nvSpPr>
-        <p:spPr>
-          <a:xfrm>
-            <a:off x="356616" y="5971031"/>
-            <a:ext cx="2633472" cy="502920"/>
-          </a:xfrm>
-          <a:prstGeom prst="rect">
-            <a:avLst/>
-          </a:prstGeom>
-          <a:noFill/>
-        </p:spPr>
-        <p:txBody>
-          <a:bodyPr wrap="none">
-            <a:spAutoFit/>
-          </a:bodyPr>
-          <a:lstStyle/>
-          <a:p>
-            <a:pPr algn="ctr">
-              <a:defRPr sz="900" b="1">
-                <a:latin typeface="Arial"/>
-              </a:defRPr>
-            </a:pPr>
-            <a:r>
-              <a:t>T Temperature Input</a:t>
-            </a:r>
-          </a:p>
-          <a:p>
-            <a:pPr algn="ctr">
-              <a:defRPr sz="700">
-                <a:solidFill>
-                  <a:srgbClr val="5F646E"/>
-                </a:solidFill>
-                <a:latin typeface="Arial"/>
-              </a:defRPr>
-            </a:pPr>
-            <a:r>
-              <a:t>T</a:t>
-            </a:r>
-          </a:p>
-        </p:txBody>
-      </p:sp>
-      <p:sp>
-        <p:nvSpPr>
-          <p:cNvPr id="17" name="Rectangle 16"/>
-          <p:cNvSpPr/>
-          <p:nvPr/>
-        </p:nvSpPr>
-        <p:spPr>
-          <a:xfrm>
-            <a:off x="3227832" y="3657600"/>
-            <a:ext cx="2889503" cy="2935224"/>
-          </a:xfrm>
-          <a:prstGeom prst="rect">
-            <a:avLst/>
-          </a:prstGeom>
-          <a:solidFill>
-            <a:srgbClr val="FAFBFD"/>
-          </a:solidFill>
-          <a:ln w="8890">
-            <a:solidFill>
-              <a:srgbClr val="D7DCE5"/>
-            </a:solidFill>
-          </a:ln>
-        </p:spPr>
-        <p:style>
-          <a:lnRef idx="1">
-            <a:schemeClr val="accent1"/>
-          </a:lnRef>
-          <a:fillRef idx="3">
-            <a:schemeClr val="accent1"/>
-          </a:fillRef>
-          <a:effectRef idx="2">
-            <a:schemeClr val="accent1"/>
-          </a:effectRef>
-          <a:fontRef idx="minor">
-            <a:schemeClr val="lt1"/>
-          </a:fontRef>
-        </p:style>
-        <p:txBody>
-          <a:bodyPr rtlCol="0" anchor="ctr"/>
-          <a:lstStyle/>
-          <a:p>
-            <a:pPr algn="ctr"/>
-          </a:p>
-        </p:txBody>
-      </p:sp>
-      <p:sp>
-        <p:nvSpPr>
-          <p:cNvPr id="18" name="TextBox 17"/>
-          <p:cNvSpPr txBox="1"/>
-          <p:nvPr/>
-        </p:nvSpPr>
-        <p:spPr>
-          <a:xfrm>
-            <a:off x="3355848" y="5971031"/>
-            <a:ext cx="2633472" cy="502920"/>
-          </a:xfrm>
-          <a:prstGeom prst="rect">
-            <a:avLst/>
-          </a:prstGeom>
-          <a:noFill/>
-        </p:spPr>
-        <p:txBody>
-          <a:bodyPr wrap="none">
-            <a:spAutoFit/>
-          </a:bodyPr>
-          <a:lstStyle/>
-          <a:p>
-            <a:pPr algn="ctr">
-              <a:defRPr sz="900" b="1">
-                <a:latin typeface="Arial"/>
-              </a:defRPr>
-            </a:pPr>
-            <a:r>
-              <a:t>TS Temperature Sensor</a:t>
-            </a:r>
-          </a:p>
-        </p:txBody>
-      </p:sp>
-      <p:sp>
-        <p:nvSpPr>
-          <p:cNvPr id="19" name="Rectangle 18"/>
-          <p:cNvSpPr/>
-          <p:nvPr/>
-        </p:nvSpPr>
-        <p:spPr>
-          <a:xfrm>
-            <a:off x="6227064" y="3657600"/>
-            <a:ext cx="2889503" cy="2935224"/>
-          </a:xfrm>
-          <a:prstGeom prst="rect">
-            <a:avLst/>
-          </a:prstGeom>
-          <a:solidFill>
-            <a:srgbClr val="FAFBFD"/>
-          </a:solidFill>
-          <a:ln w="8890">
-            <a:solidFill>
-              <a:srgbClr val="D7DCE5"/>
-            </a:solidFill>
-          </a:ln>
-        </p:spPr>
-        <p:style>
-          <a:lnRef idx="1">
-            <a:schemeClr val="accent1"/>
-          </a:lnRef>
-          <a:fillRef idx="3">
-            <a:schemeClr val="accent1"/>
-          </a:fillRef>
-          <a:effectRef idx="2">
-            <a:schemeClr val="accent1"/>
-          </a:effectRef>
-          <a:fontRef idx="minor">
-            <a:schemeClr val="lt1"/>
-          </a:fontRef>
-        </p:style>
-        <p:txBody>
-          <a:bodyPr rtlCol="0" anchor="ctr"/>
-          <a:lstStyle/>
-          <a:p>
-            <a:pPr algn="ctr"/>
-          </a:p>
-        </p:txBody>
-      </p:sp>
-      <p:sp>
-        <p:nvSpPr>
-          <p:cNvPr id="20" name="TextBox 19"/>
-          <p:cNvSpPr txBox="1"/>
-          <p:nvPr/>
-        </p:nvSpPr>
-        <p:spPr>
-          <a:xfrm>
-            <a:off x="6355079" y="5971031"/>
-            <a:ext cx="2633472" cy="502920"/>
-          </a:xfrm>
-          <a:prstGeom prst="rect">
-            <a:avLst/>
-          </a:prstGeom>
-          <a:noFill/>
-        </p:spPr>
-        <p:txBody>
-          <a:bodyPr wrap="none">
-            <a:spAutoFit/>
-          </a:bodyPr>
-          <a:lstStyle/>
-          <a:p>
-            <a:pPr algn="ctr">
-              <a:defRPr sz="900" b="1">
-                <a:latin typeface="Arial"/>
-              </a:defRPr>
-            </a:pPr>
-            <a:r>
-              <a:t>When Lit Refrigerant Leak — Do Not Enter Sign</a:t>
-            </a:r>
-          </a:p>
-        </p:txBody>
-      </p:sp>
-      <p:sp>
-        <p:nvSpPr>
-          <p:cNvPr id="21" name="Rectangle 20"/>
-          <p:cNvSpPr/>
-          <p:nvPr/>
-        </p:nvSpPr>
-        <p:spPr>
-          <a:xfrm>
-            <a:off x="9226296" y="3657600"/>
-            <a:ext cx="2889503" cy="2935224"/>
-          </a:xfrm>
-          <a:prstGeom prst="rect">
-            <a:avLst/>
-          </a:prstGeom>
-          <a:solidFill>
-            <a:srgbClr val="FAFBFD"/>
-          </a:solidFill>
-          <a:ln w="8890">
-            <a:solidFill>
-              <a:srgbClr val="D7DCE5"/>
-            </a:solidFill>
-          </a:ln>
-        </p:spPr>
-        <p:style>
-          <a:lnRef idx="1">
-            <a:schemeClr val="accent1"/>
-          </a:lnRef>
-          <a:fillRef idx="3">
-            <a:schemeClr val="accent1"/>
-          </a:fillRef>
-          <a:effectRef idx="2">
-            <a:schemeClr val="accent1"/>
-          </a:effectRef>
-          <a:fontRef idx="minor">
-            <a:schemeClr val="lt1"/>
-          </a:fontRef>
-        </p:style>
-        <p:txBody>
-          <a:bodyPr rtlCol="0" anchor="ctr"/>
-          <a:lstStyle/>
-          <a:p>
-            <a:pPr algn="ctr"/>
-          </a:p>
-        </p:txBody>
-      </p:sp>
-      <p:sp>
-        <p:nvSpPr>
-          <p:cNvPr id="22" name="TextBox 21"/>
-          <p:cNvSpPr txBox="1"/>
-          <p:nvPr/>
-        </p:nvSpPr>
-        <p:spPr>
-          <a:xfrm>
-            <a:off x="9354312" y="5971031"/>
-            <a:ext cx="2633472" cy="502920"/>
-          </a:xfrm>
-          <a:prstGeom prst="rect">
-            <a:avLst/>
-          </a:prstGeom>
-          <a:noFill/>
-        </p:spPr>
-        <p:txBody>
-          <a:bodyPr wrap="none">
-            <a:spAutoFit/>
-          </a:bodyPr>
-          <a:lstStyle/>
-          <a:p>
-            <a:pPr algn="ctr">
-              <a:defRPr sz="900" b="1">
-                <a:latin typeface="Arial"/>
-              </a:defRPr>
-            </a:pPr>
-            <a:r>
-              <a:t>WICP Location Callout</a:t>
-            </a:r>
-          </a:p>
-          <a:p>
-            <a:pPr algn="ctr">
-              <a:defRPr sz="700">
-                <a:solidFill>
-                  <a:srgbClr val="5F646E"/>
-                </a:solidFill>
-                <a:latin typeface="Arial"/>
-              </a:defRPr>
-            </a:pPr>
-            <a:r>
-              <a:t>3</a:t>
-            </a:r>
-          </a:p>
-        </p:txBody>
-      </p:sp>
-      <p:sp>
-        <p:nvSpPr>
-          <p:cNvPr id="23" name="Rectangle 22"/>
-          <p:cNvSpPr/>
-          <p:nvPr/>
-        </p:nvSpPr>
-        <p:spPr>
-          <a:xfrm>
-            <a:off x="12225528" y="3657600"/>
-            <a:ext cx="2889503" cy="2935224"/>
-          </a:xfrm>
-          <a:prstGeom prst="rect">
-            <a:avLst/>
-          </a:prstGeom>
-          <a:solidFill>
-            <a:srgbClr val="FAFBFD"/>
-          </a:solidFill>
-          <a:ln w="8890">
-            <a:solidFill>
-              <a:srgbClr val="D7DCE5"/>
-            </a:solidFill>
-          </a:ln>
-        </p:spPr>
-        <p:style>
-          <a:lnRef idx="1">
-            <a:schemeClr val="accent1"/>
-          </a:lnRef>
-          <a:fillRef idx="3">
-            <a:schemeClr val="accent1"/>
-          </a:fillRef>
-          <a:effectRef idx="2">
-            <a:schemeClr val="accent1"/>
-          </a:effectRef>
-          <a:fontRef idx="minor">
-            <a:schemeClr val="lt1"/>
-          </a:fontRef>
-        </p:style>
-        <p:txBody>
-          <a:bodyPr rtlCol="0" anchor="ctr"/>
-          <a:lstStyle/>
-          <a:p>
-            <a:pPr algn="ctr"/>
-          </a:p>
-        </p:txBody>
-      </p:sp>
-      <p:sp>
-        <p:nvSpPr>
-          <p:cNvPr id="24" name="TextBox 23"/>
-          <p:cNvSpPr txBox="1"/>
-          <p:nvPr/>
-        </p:nvSpPr>
-        <p:spPr>
-          <a:xfrm>
-            <a:off x="12353544" y="5971031"/>
-            <a:ext cx="2633472" cy="502920"/>
-          </a:xfrm>
-          <a:prstGeom prst="rect">
-            <a:avLst/>
-          </a:prstGeom>
-          <a:noFill/>
-        </p:spPr>
-        <p:txBody>
-          <a:bodyPr wrap="none">
-            <a:spAutoFit/>
-          </a:bodyPr>
-          <a:lstStyle/>
-          <a:p>
-            <a:pPr algn="ctr">
-              <a:defRPr sz="900" b="1">
-                <a:latin typeface="Arial"/>
-              </a:defRPr>
-            </a:pPr>
-            <a:r>
-              <a:t>WICP Location Callout</a:t>
-            </a:r>
-          </a:p>
-          <a:p>
-            <a:pPr algn="ctr">
-              <a:defRPr sz="700">
-                <a:solidFill>
-                  <a:srgbClr val="5F646E"/>
-                </a:solidFill>
-                <a:latin typeface="Arial"/>
-              </a:defRPr>
-            </a:pPr>
-            <a:r>
-              <a:t>3</a:t>
-            </a:r>
-          </a:p>
-        </p:txBody>
-      </p:sp>
-      <p:sp>
-        <p:nvSpPr>
-          <p:cNvPr id="25" name="Rectangle 24"/>
-          <p:cNvSpPr/>
-          <p:nvPr/>
-        </p:nvSpPr>
-        <p:spPr>
-          <a:xfrm>
-            <a:off x="228600" y="6720840"/>
-            <a:ext cx="2889503" cy="2935224"/>
-          </a:xfrm>
-          <a:prstGeom prst="rect">
-            <a:avLst/>
-          </a:prstGeom>
-          <a:solidFill>
-            <a:srgbClr val="FAFBFD"/>
-          </a:solidFill>
-          <a:ln w="8890">
-            <a:solidFill>
-              <a:srgbClr val="D7DCE5"/>
-            </a:solidFill>
-          </a:ln>
-        </p:spPr>
-        <p:style>
-          <a:lnRef idx="1">
-            <a:schemeClr val="accent1"/>
-          </a:lnRef>
-          <a:fillRef idx="3">
-            <a:schemeClr val="accent1"/>
-          </a:fillRef>
-          <a:effectRef idx="2">
-            <a:schemeClr val="accent1"/>
-          </a:effectRef>
-          <a:fontRef idx="minor">
-            <a:schemeClr val="lt1"/>
-          </a:fontRef>
-        </p:style>
-        <p:txBody>
-          <a:bodyPr rtlCol="0" anchor="ctr"/>
-          <a:lstStyle/>
-          <a:p>
-            <a:pPr algn="ctr"/>
-          </a:p>
-        </p:txBody>
-      </p:sp>
-      <p:sp>
-        <p:nvSpPr>
-          <p:cNvPr id="26" name="TextBox 25"/>
-          <p:cNvSpPr txBox="1"/>
-          <p:nvPr/>
-        </p:nvSpPr>
-        <p:spPr>
-          <a:xfrm>
-            <a:off x="356616" y="9034272"/>
-            <a:ext cx="2633472" cy="502920"/>
-          </a:xfrm>
-          <a:prstGeom prst="rect">
-            <a:avLst/>
-          </a:prstGeom>
-          <a:noFill/>
-        </p:spPr>
-        <p:txBody>
-          <a:bodyPr wrap="none">
-            <a:spAutoFit/>
-          </a:bodyPr>
-          <a:lstStyle/>
-          <a:p>
-            <a:pPr algn="ctr">
-              <a:defRPr sz="900" b="1">
-                <a:latin typeface="Arial"/>
-              </a:defRPr>
-            </a:pPr>
-            <a:r>
-              <a:t>WICP Panel Marker</a:t>
-            </a:r>
-          </a:p>
-          <a:p>
-            <a:pPr algn="ctr">
-              <a:defRPr sz="700">
-                <a:solidFill>
-                  <a:srgbClr val="5F646E"/>
-                </a:solidFill>
-                <a:latin typeface="Arial"/>
-              </a:defRPr>
-            </a:pPr>
-            <a:r>
-              <a:t>WICP</a:t>
-            </a:r>
-          </a:p>
-        </p:txBody>
-      </p:sp>
-    </p:spTree>
-  </p:cSld>
-  <p:clrMapOvr>
-    <a:masterClrMapping/>
-  </p:clrMapOvr>
-</p:sld>
-</file>
-
 <file path=ppt/slides/slide3.xml><?xml version="1.0" encoding="utf-8"?>
 <p:sld xmlns:a="http://schemas.openxmlformats.org/drawingml/2006/main" xmlns:p="http://schemas.openxmlformats.org/presentationml/2006/main" xmlns:r="http://schemas.openxmlformats.org/officeDocument/2006/relationships">
   <p:cSld>
@@ -17485,9 +16295,33 @@
           </a:p>
         </p:txBody>
       </p:sp>
-      <p:sp>
-        <p:nvSpPr>
-          <p:cNvPr id="5" name="TextBox 4"/>
+      <p:pic>
+        <p:nvPicPr>
+          <p:cNvPr id="5" name="S360_COMPONENT_ID=dent_powerscout_ps12|VARIANT=edge" descr="dent_powerscout_ps12__edge.png"/>
+          <p:cNvPicPr>
+            <a:picLocks noChangeAspect="1"/>
+          </p:cNvPicPr>
+          <p:nvPr/>
+        </p:nvPicPr>
+        <p:blipFill>
+          <a:blip r:embed="rId2"/>
+          <a:stretch>
+            <a:fillRect/>
+          </a:stretch>
+        </p:blipFill>
+        <p:spPr>
+          <a:xfrm>
+            <a:off x="1054227" y="1436370"/>
+            <a:ext cx="1238250" cy="876300"/>
+          </a:xfrm>
+          <a:prstGeom prst="rect">
+            <a:avLst/>
+          </a:prstGeom>
+        </p:spPr>
+      </p:pic>
+      <p:sp>
+        <p:nvSpPr>
+          <p:cNvPr id="6" name="TextBox 5"/>
           <p:cNvSpPr txBox="1"/>
           <p:nvPr/>
         </p:nvSpPr>
@@ -17513,7 +16347,7 @@
               </a:defRPr>
             </a:pPr>
             <a:r>
-              <a:t>DS Door Switch</a:t>
+              <a:t>DENT PowerScout PS12</a:t>
             </a:r>
           </a:p>
           <a:p>
@@ -17526,14 +16360,14 @@
               </a:defRPr>
             </a:pPr>
             <a:r>
-              <a:t>DS</a:t>
-            </a:r>
-          </a:p>
-        </p:txBody>
-      </p:sp>
-      <p:sp>
-        <p:nvSpPr>
-          <p:cNvPr id="6" name="Rectangle 5"/>
+              <a:t>PS12HD-C-D-N</a:t>
+            </a:r>
+          </a:p>
+        </p:txBody>
+      </p:sp>
+      <p:sp>
+        <p:nvSpPr>
+          <p:cNvPr id="7" name="Rectangle 6"/>
           <p:cNvSpPr/>
           <p:nvPr/>
         </p:nvSpPr>
@@ -17576,9 +16410,33 @@
           </a:p>
         </p:txBody>
       </p:sp>
-      <p:sp>
-        <p:nvSpPr>
-          <p:cNvPr id="7" name="TextBox 6"/>
+      <p:pic>
+        <p:nvPicPr>
+          <p:cNvPr id="8" name="S360_COMPONENT_ID=dent_powerscout_ps24|VARIANT=edge" descr="dent_powerscout_ps24__edge.png"/>
+          <p:cNvPicPr>
+            <a:picLocks noChangeAspect="1"/>
+          </p:cNvPicPr>
+          <p:nvPr/>
+        </p:nvPicPr>
+        <p:blipFill>
+          <a:blip r:embed="rId3"/>
+          <a:stretch>
+            <a:fillRect/>
+          </a:stretch>
+        </p:blipFill>
+        <p:spPr>
+          <a:xfrm>
+            <a:off x="4053458" y="1436370"/>
+            <a:ext cx="1238250" cy="876300"/>
+          </a:xfrm>
+          <a:prstGeom prst="rect">
+            <a:avLst/>
+          </a:prstGeom>
+        </p:spPr>
+      </p:pic>
+      <p:sp>
+        <p:nvSpPr>
+          <p:cNvPr id="9" name="TextBox 8"/>
           <p:cNvSpPr txBox="1"/>
           <p:nvPr/>
         </p:nvSpPr>
@@ -17604,7 +16462,7 @@
               </a:defRPr>
             </a:pPr>
             <a:r>
-              <a:t>ET Entrapment Switch</a:t>
+              <a:t>DENT PowerScout PS24</a:t>
             </a:r>
           </a:p>
           <a:p>
@@ -17617,14 +16475,14 @@
               </a:defRPr>
             </a:pPr>
             <a:r>
-              <a:t>ET</a:t>
-            </a:r>
-          </a:p>
-        </p:txBody>
-      </p:sp>
-      <p:sp>
-        <p:nvSpPr>
-          <p:cNvPr id="8" name="Rectangle 7"/>
+              <a:t>PS24HD-C-D-N</a:t>
+            </a:r>
+          </a:p>
+        </p:txBody>
+      </p:sp>
+      <p:sp>
+        <p:nvSpPr>
+          <p:cNvPr id="10" name="Rectangle 9"/>
           <p:cNvSpPr/>
           <p:nvPr/>
         </p:nvSpPr>
@@ -17667,9 +16525,33 @@
           </a:p>
         </p:txBody>
       </p:sp>
-      <p:sp>
-        <p:nvSpPr>
-          <p:cNvPr id="9" name="TextBox 8"/>
+      <p:pic>
+        <p:nvPicPr>
+          <p:cNvPr id="11" name="S360_COMPONENT_ID=dent_powerscout_ps3|VARIANT=edge" descr="dent_powerscout_ps3__edge.png"/>
+          <p:cNvPicPr>
+            <a:picLocks noChangeAspect="1"/>
+          </p:cNvPicPr>
+          <p:nvPr/>
+        </p:nvPicPr>
+        <p:blipFill>
+          <a:blip r:embed="rId4"/>
+          <a:stretch>
+            <a:fillRect/>
+          </a:stretch>
+        </p:blipFill>
+        <p:spPr>
+          <a:xfrm>
+            <a:off x="7052690" y="1436370"/>
+            <a:ext cx="1238250" cy="876300"/>
+          </a:xfrm>
+          <a:prstGeom prst="rect">
+            <a:avLst/>
+          </a:prstGeom>
+        </p:spPr>
+      </p:pic>
+      <p:sp>
+        <p:nvSpPr>
+          <p:cNvPr id="12" name="TextBox 11"/>
           <p:cNvSpPr txBox="1"/>
           <p:nvPr/>
         </p:nvSpPr>
@@ -17695,7 +16577,7 @@
               </a:defRPr>
             </a:pPr>
             <a:r>
-              <a:t>LLSV Liquid Line Solenoid Valve</a:t>
+              <a:t>DENT PowerScout PS3</a:t>
             </a:r>
           </a:p>
           <a:p>
@@ -17708,14 +16590,14 @@
               </a:defRPr>
             </a:pPr>
             <a:r>
-              <a:t>LLSV</a:t>
-            </a:r>
-          </a:p>
-        </p:txBody>
-      </p:sp>
-      <p:sp>
-        <p:nvSpPr>
-          <p:cNvPr id="10" name="Rectangle 9"/>
+              <a:t>PS3HD-C-D-N</a:t>
+            </a:r>
+          </a:p>
+        </p:txBody>
+      </p:sp>
+      <p:sp>
+        <p:nvSpPr>
+          <p:cNvPr id="13" name="Rectangle 12"/>
           <p:cNvSpPr/>
           <p:nvPr/>
         </p:nvSpPr>
@@ -17758,9 +16640,33 @@
           </a:p>
         </p:txBody>
       </p:sp>
-      <p:sp>
-        <p:nvSpPr>
-          <p:cNvPr id="11" name="TextBox 10"/>
+      <p:pic>
+        <p:nvPicPr>
+          <p:cNvPr id="14" name="S360_COMPONENT_ID=dent_powerscout_ps48|VARIANT=edge" descr="dent_powerscout_ps48__edge.png"/>
+          <p:cNvPicPr>
+            <a:picLocks noChangeAspect="1"/>
+          </p:cNvPicPr>
+          <p:nvPr/>
+        </p:nvPicPr>
+        <p:blipFill>
+          <a:blip r:embed="rId5"/>
+          <a:stretch>
+            <a:fillRect/>
+          </a:stretch>
+        </p:blipFill>
+        <p:spPr>
+          <a:xfrm>
+            <a:off x="10051923" y="1436370"/>
+            <a:ext cx="1238250" cy="876300"/>
+          </a:xfrm>
+          <a:prstGeom prst="rect">
+            <a:avLst/>
+          </a:prstGeom>
+        </p:spPr>
+      </p:pic>
+      <p:sp>
+        <p:nvSpPr>
+          <p:cNvPr id="15" name="TextBox 14"/>
           <p:cNvSpPr txBox="1"/>
           <p:nvPr/>
         </p:nvSpPr>
@@ -17786,7 +16692,7 @@
               </a:defRPr>
             </a:pPr>
             <a:r>
-              <a:t>Powerscout PS12 Meter</a:t>
+              <a:t>DENT PowerScout PS48</a:t>
             </a:r>
           </a:p>
           <a:p>
@@ -17799,14 +16705,14 @@
               </a:defRPr>
             </a:pPr>
             <a:r>
-              <a:t>PS12</a:t>
-            </a:r>
-          </a:p>
-        </p:txBody>
-      </p:sp>
-      <p:sp>
-        <p:nvSpPr>
-          <p:cNvPr id="12" name="Rectangle 11"/>
+              <a:t>PS48HD-C-D-N</a:t>
+            </a:r>
+          </a:p>
+        </p:txBody>
+      </p:sp>
+      <p:sp>
+        <p:nvSpPr>
+          <p:cNvPr id="16" name="Rectangle 15"/>
           <p:cNvSpPr/>
           <p:nvPr/>
         </p:nvSpPr>
@@ -17851,7 +16757,7 @@
       </p:sp>
       <p:sp>
         <p:nvSpPr>
-          <p:cNvPr id="13" name="TextBox 12"/>
+          <p:cNvPr id="17" name="TextBox 16"/>
           <p:cNvSpPr txBox="1"/>
           <p:nvPr/>
         </p:nvSpPr>
@@ -17877,7 +16783,7 @@
               </a:defRPr>
             </a:pPr>
             <a:r>
-              <a:t>Powerscout PS24 Meter</a:t>
+              <a:t>DS Door Switch</a:t>
             </a:r>
           </a:p>
           <a:p>
@@ -17890,14 +16796,14 @@
               </a:defRPr>
             </a:pPr>
             <a:r>
-              <a:t>PS24</a:t>
-            </a:r>
-          </a:p>
-        </p:txBody>
-      </p:sp>
-      <p:sp>
-        <p:nvSpPr>
-          <p:cNvPr id="14" name="Rectangle 13"/>
+              <a:t>DS</a:t>
+            </a:r>
+          </a:p>
+        </p:txBody>
+      </p:sp>
+      <p:sp>
+        <p:nvSpPr>
+          <p:cNvPr id="18" name="Rectangle 17"/>
           <p:cNvSpPr/>
           <p:nvPr/>
         </p:nvSpPr>
@@ -17942,7 +16848,7 @@
       </p:sp>
       <p:sp>
         <p:nvSpPr>
-          <p:cNvPr id="15" name="TextBox 14"/>
+          <p:cNvPr id="19" name="TextBox 18"/>
           <p:cNvSpPr txBox="1"/>
           <p:nvPr/>
         </p:nvSpPr>
@@ -17968,7 +16874,7 @@
               </a:defRPr>
             </a:pPr>
             <a:r>
-              <a:t>Powerscout PS3 Meter</a:t>
+              <a:t>ET Entrapment Switch</a:t>
             </a:r>
           </a:p>
           <a:p>
@@ -17981,14 +16887,14 @@
               </a:defRPr>
             </a:pPr>
             <a:r>
-              <a:t>PS3</a:t>
-            </a:r>
-          </a:p>
-        </p:txBody>
-      </p:sp>
-      <p:sp>
-        <p:nvSpPr>
-          <p:cNvPr id="16" name="Rectangle 15"/>
+              <a:t>ET</a:t>
+            </a:r>
+          </a:p>
+        </p:txBody>
+      </p:sp>
+      <p:sp>
+        <p:nvSpPr>
+          <p:cNvPr id="20" name="Rectangle 19"/>
           <p:cNvSpPr/>
           <p:nvPr/>
         </p:nvSpPr>
@@ -18031,33 +16937,9 @@
           </a:p>
         </p:txBody>
       </p:sp>
-      <p:pic>
-        <p:nvPicPr>
-          <p:cNvPr id="17" name="S360_COMPONENT_ID=dent_powerscout_ps48|VARIANT=edge" descr="dent_powerscout_ps48__edge.png"/>
-          <p:cNvPicPr>
-            <a:picLocks noChangeAspect="1"/>
-          </p:cNvPicPr>
-          <p:nvPr/>
-        </p:nvPicPr>
-        <p:blipFill>
-          <a:blip r:embed="rId2"/>
-          <a:stretch>
-            <a:fillRect/>
-          </a:stretch>
-        </p:blipFill>
-        <p:spPr>
-          <a:xfrm>
-            <a:off x="3424428" y="4313682"/>
-            <a:ext cx="2496311" cy="1248155"/>
-          </a:xfrm>
-          <a:prstGeom prst="rect">
-            <a:avLst/>
-          </a:prstGeom>
-        </p:spPr>
-      </p:pic>
-      <p:sp>
-        <p:nvSpPr>
-          <p:cNvPr id="18" name="TextBox 17"/>
+      <p:sp>
+        <p:nvSpPr>
+          <p:cNvPr id="21" name="TextBox 20"/>
           <p:cNvSpPr txBox="1"/>
           <p:nvPr/>
         </p:nvSpPr>
@@ -18083,7 +16965,7 @@
               </a:defRPr>
             </a:pPr>
             <a:r>
-              <a:t>PowerScout PS48</a:t>
+              <a:t>LLSV Liquid Line Solenoid Valve</a:t>
             </a:r>
           </a:p>
           <a:p>
@@ -18096,14 +16978,14 @@
               </a:defRPr>
             </a:pPr>
             <a:r>
-              <a:t>PS48</a:t>
-            </a:r>
-          </a:p>
-        </p:txBody>
-      </p:sp>
-      <p:sp>
-        <p:nvSpPr>
-          <p:cNvPr id="19" name="Rectangle 18"/>
+              <a:t>LLSV</a:t>
+            </a:r>
+          </a:p>
+        </p:txBody>
+      </p:sp>
+      <p:sp>
+        <p:nvSpPr>
+          <p:cNvPr id="22" name="Rectangle 21"/>
           <p:cNvSpPr/>
           <p:nvPr/>
         </p:nvSpPr>
@@ -18146,9 +17028,33 @@
           </a:p>
         </p:txBody>
       </p:sp>
-      <p:sp>
-        <p:nvSpPr>
-          <p:cNvPr id="20" name="TextBox 19"/>
+      <p:pic>
+        <p:nvPicPr>
+          <p:cNvPr id="23" name="S360_COMPONENT_ID=rdm_rdm_bluetooth|VARIANT=edge" descr="rdm_rdm_bluetooth__lineart.png"/>
+          <p:cNvPicPr>
+            <a:picLocks noChangeAspect="1"/>
+          </p:cNvPicPr>
+          <p:nvPr/>
+        </p:nvPicPr>
+        <p:blipFill>
+          <a:blip r:embed="rId6"/>
+          <a:stretch>
+            <a:fillRect/>
+          </a:stretch>
+        </p:blipFill>
+        <p:spPr>
+          <a:xfrm>
+            <a:off x="7100316" y="4737735"/>
+            <a:ext cx="1143000" cy="400050"/>
+          </a:xfrm>
+          <a:prstGeom prst="rect">
+            <a:avLst/>
+          </a:prstGeom>
+        </p:spPr>
+      </p:pic>
+      <p:sp>
+        <p:nvSpPr>
+          <p:cNvPr id="24" name="TextBox 23"/>
           <p:cNvSpPr txBox="1"/>
           <p:nvPr/>
         </p:nvSpPr>
@@ -18174,27 +17080,14 @@
               </a:defRPr>
             </a:pPr>
             <a:r>
-              <a:t>Powerscout PS48 Meter</a:t>
-            </a:r>
-          </a:p>
-          <a:p>
-            <a:pPr algn="ctr">
-              <a:defRPr sz="700">
-                <a:solidFill>
-                  <a:srgbClr val="5F646E"/>
-                </a:solidFill>
-                <a:latin typeface="Arial"/>
-              </a:defRPr>
-            </a:pPr>
-            <a:r>
-              <a:t>PS48</a:t>
-            </a:r>
-          </a:p>
-        </p:txBody>
-      </p:sp>
-      <p:sp>
-        <p:nvSpPr>
-          <p:cNvPr id="21" name="Rectangle 20"/>
+              <a:t>RDM Bluetooth</a:t>
+            </a:r>
+          </a:p>
+        </p:txBody>
+      </p:sp>
+      <p:sp>
+        <p:nvSpPr>
+          <p:cNvPr id="25" name="Rectangle 24"/>
           <p:cNvSpPr/>
           <p:nvPr/>
         </p:nvSpPr>
@@ -18237,33 +17130,9 @@
           </a:p>
         </p:txBody>
       </p:sp>
-      <p:pic>
-        <p:nvPicPr>
-          <p:cNvPr id="22" name="S360_COMPONENT_ID=rdm_rdm_bluetooth|VARIANT=edge" descr="rdm_rdm_bluetooth__lineart.png"/>
-          <p:cNvPicPr>
-            <a:picLocks noChangeAspect="1"/>
-          </p:cNvPicPr>
-          <p:nvPr/>
-        </p:nvPicPr>
-        <p:blipFill>
-          <a:blip r:embed="rId3"/>
-          <a:stretch>
-            <a:fillRect/>
-          </a:stretch>
-        </p:blipFill>
-        <p:spPr>
-          <a:xfrm>
-            <a:off x="10099548" y="4737735"/>
-            <a:ext cx="1143000" cy="400050"/>
-          </a:xfrm>
-          <a:prstGeom prst="rect">
-            <a:avLst/>
-          </a:prstGeom>
-        </p:spPr>
-      </p:pic>
-      <p:sp>
-        <p:nvSpPr>
-          <p:cNvPr id="23" name="TextBox 22"/>
+      <p:sp>
+        <p:nvSpPr>
+          <p:cNvPr id="26" name="TextBox 25"/>
           <p:cNvSpPr txBox="1"/>
           <p:nvPr/>
         </p:nvSpPr>
@@ -18289,14 +17158,27 @@
               </a:defRPr>
             </a:pPr>
             <a:r>
-              <a:t>RDM Bluetooth</a:t>
-            </a:r>
-          </a:p>
-        </p:txBody>
-      </p:sp>
-      <p:sp>
-        <p:nvSpPr>
-          <p:cNvPr id="24" name="Rectangle 23"/>
+              <a:t>Rogowski Coil CT</a:t>
+            </a:r>
+          </a:p>
+          <a:p>
+            <a:pPr algn="ctr">
+              <a:defRPr sz="700">
+                <a:solidFill>
+                  <a:srgbClr val="5F646E"/>
+                </a:solidFill>
+                <a:latin typeface="Arial"/>
+              </a:defRPr>
+            </a:pPr>
+            <a:r>
+              <a:t>CT-R36</a:t>
+            </a:r>
+          </a:p>
+        </p:txBody>
+      </p:sp>
+      <p:sp>
+        <p:nvSpPr>
+          <p:cNvPr id="27" name="Rectangle 26"/>
           <p:cNvSpPr/>
           <p:nvPr/>
         </p:nvSpPr>
@@ -18341,104 +17223,13 @@
       </p:sp>
       <p:sp>
         <p:nvSpPr>
-          <p:cNvPr id="25" name="TextBox 24"/>
+          <p:cNvPr id="28" name="TextBox 27"/>
           <p:cNvSpPr txBox="1"/>
           <p:nvPr/>
         </p:nvSpPr>
         <p:spPr>
           <a:xfrm>
             <a:off x="12353544" y="5971031"/>
-            <a:ext cx="2633472" cy="502920"/>
-          </a:xfrm>
-          <a:prstGeom prst="rect">
-            <a:avLst/>
-          </a:prstGeom>
-          <a:noFill/>
-        </p:spPr>
-        <p:txBody>
-          <a:bodyPr wrap="none">
-            <a:spAutoFit/>
-          </a:bodyPr>
-          <a:lstStyle/>
-          <a:p>
-            <a:pPr algn="ctr">
-              <a:defRPr sz="900" b="1">
-                <a:latin typeface="Arial"/>
-              </a:defRPr>
-            </a:pPr>
-            <a:r>
-              <a:t>Rogowski Coil CT</a:t>
-            </a:r>
-          </a:p>
-          <a:p>
-            <a:pPr algn="ctr">
-              <a:defRPr sz="700">
-                <a:solidFill>
-                  <a:srgbClr val="5F646E"/>
-                </a:solidFill>
-                <a:latin typeface="Arial"/>
-              </a:defRPr>
-            </a:pPr>
-            <a:r>
-              <a:t>CT-R36</a:t>
-            </a:r>
-          </a:p>
-        </p:txBody>
-      </p:sp>
-      <p:sp>
-        <p:nvSpPr>
-          <p:cNvPr id="26" name="Rectangle 25"/>
-          <p:cNvSpPr/>
-          <p:nvPr/>
-        </p:nvSpPr>
-        <p:spPr>
-          <a:xfrm>
-            <a:off x="228600" y="6720840"/>
-            <a:ext cx="2889503" cy="2935224"/>
-          </a:xfrm>
-          <a:prstGeom prst="rect">
-            <a:avLst/>
-          </a:prstGeom>
-          <a:solidFill>
-            <a:srgbClr val="FAFBFD"/>
-          </a:solidFill>
-          <a:ln w="8890">
-            <a:solidFill>
-              <a:srgbClr val="D7DCE5"/>
-            </a:solidFill>
-          </a:ln>
-        </p:spPr>
-        <p:style>
-          <a:lnRef idx="1">
-            <a:schemeClr val="accent1"/>
-          </a:lnRef>
-          <a:fillRef idx="3">
-            <a:schemeClr val="accent1"/>
-          </a:fillRef>
-          <a:effectRef idx="2">
-            <a:schemeClr val="accent1"/>
-          </a:effectRef>
-          <a:fontRef idx="minor">
-            <a:schemeClr val="lt1"/>
-          </a:fontRef>
-        </p:style>
-        <p:txBody>
-          <a:bodyPr rtlCol="0" anchor="ctr"/>
-          <a:lstStyle/>
-          <a:p>
-            <a:pPr algn="ctr"/>
-          </a:p>
-        </p:txBody>
-      </p:sp>
-      <p:sp>
-        <p:nvSpPr>
-          <p:cNvPr id="27" name="TextBox 26"/>
-          <p:cNvSpPr txBox="1"/>
-          <p:nvPr/>
-        </p:nvSpPr>
-        <p:spPr>
-          <a:xfrm>
-            <a:off x="356616" y="9034272"/>
             <a:ext cx="2633472" cy="502920"/>
           </a:xfrm>
           <a:prstGeom prst="rect">

</xml_diff>

<commit_message>
Unify component library views and restore core logos
</commit_message>
<xml_diff>
--- a/docs/component-library/Singh360_Component_Library_Edge.pptx
+++ b/docs/component-library/Singh360_Component_Library_Edge.pptx
@@ -24,6 +24,7 @@
     <p:sldId id="272" r:id="rId23"/>
     <p:sldId id="273" r:id="rId24"/>
     <p:sldId id="274" r:id="rId25"/>
+    <p:sldId id="275" r:id="rId26"/>
   </p:sldIdLst>
   <p:sldSz cx="15544800" cy="10058400" type="screen4x3"/>
   <p:notesSz cx="6858000" cy="9144000"/>
@@ -4993,7 +4994,7 @@
       </p:sp>
       <p:pic>
         <p:nvPicPr>
-          <p:cNvPr id="5" name="S360_COMPONENT_ID=rdm_rdm_logo|VARIANT=edge" descr="rdm_rdm_logo__highcontrast.png"/>
+          <p:cNvPr id="5" name="S360_COMPONENT_ID=heb_logo|VARIANT=edge" descr="heb_logo.png"/>
           <p:cNvPicPr>
             <a:picLocks noChangeAspect="1"/>
           </p:cNvPicPr>
@@ -5007,8 +5008,8 @@
         </p:blipFill>
         <p:spPr>
           <a:xfrm>
-            <a:off x="1006601" y="1588769"/>
-            <a:ext cx="1333500" cy="571500"/>
+            <a:off x="958976" y="1579245"/>
+            <a:ext cx="1428750" cy="590550"/>
           </a:xfrm>
           <a:prstGeom prst="rect">
             <a:avLst/>
@@ -5043,7 +5044,7 @@
               </a:defRPr>
             </a:pPr>
             <a:r>
-              <a:t>RDM Logo</a:t>
+              <a:t>H-E-B Logo</a:t>
             </a:r>
           </a:p>
         </p:txBody>
@@ -5095,7 +5096,7 @@
       </p:sp>
       <p:pic>
         <p:nvPicPr>
-          <p:cNvPr id="8" name="S360_COMPONENT_ID=logos_672af5074f|VARIANT=edge" descr="Singhg360_Logo.jpg"/>
+          <p:cNvPr id="8" name="S360_COMPONENT_ID=rdm_rdm_logo|VARIANT=edge" descr="rdm_rdm_logo__highcontrast.png"/>
           <p:cNvPicPr>
             <a:picLocks noChangeAspect="1"/>
           </p:cNvPicPr>
@@ -5126,6 +5127,312 @@
         <p:spPr>
           <a:xfrm>
             <a:off x="3355848" y="2907792"/>
+            <a:ext cx="2633472" cy="502920"/>
+          </a:xfrm>
+          <a:prstGeom prst="rect">
+            <a:avLst/>
+          </a:prstGeom>
+          <a:noFill/>
+        </p:spPr>
+        <p:txBody>
+          <a:bodyPr wrap="none">
+            <a:spAutoFit/>
+          </a:bodyPr>
+          <a:lstStyle/>
+          <a:p>
+            <a:pPr algn="ctr">
+              <a:defRPr sz="900" b="1">
+                <a:latin typeface="Arial"/>
+              </a:defRPr>
+            </a:pPr>
+            <a:r>
+              <a:t>RDM Logo</a:t>
+            </a:r>
+          </a:p>
+        </p:txBody>
+      </p:sp>
+      <p:sp>
+        <p:nvSpPr>
+          <p:cNvPr id="10" name="Rectangle 9"/>
+          <p:cNvSpPr/>
+          <p:nvPr/>
+        </p:nvSpPr>
+        <p:spPr>
+          <a:xfrm>
+            <a:off x="6227064" y="594360"/>
+            <a:ext cx="2889503" cy="2935224"/>
+          </a:xfrm>
+          <a:prstGeom prst="rect">
+            <a:avLst/>
+          </a:prstGeom>
+          <a:solidFill>
+            <a:srgbClr val="FAFBFD"/>
+          </a:solidFill>
+          <a:ln w="8890">
+            <a:solidFill>
+              <a:srgbClr val="D7DCE5"/>
+            </a:solidFill>
+          </a:ln>
+        </p:spPr>
+        <p:style>
+          <a:lnRef idx="1">
+            <a:schemeClr val="accent1"/>
+          </a:lnRef>
+          <a:fillRef idx="3">
+            <a:schemeClr val="accent1"/>
+          </a:fillRef>
+          <a:effectRef idx="2">
+            <a:schemeClr val="accent1"/>
+          </a:effectRef>
+          <a:fontRef idx="minor">
+            <a:schemeClr val="lt1"/>
+          </a:fontRef>
+        </p:style>
+        <p:txBody>
+          <a:bodyPr rtlCol="0" anchor="ctr"/>
+          <a:lstStyle/>
+          <a:p>
+            <a:pPr algn="ctr"/>
+          </a:p>
+        </p:txBody>
+      </p:sp>
+      <p:pic>
+        <p:nvPicPr>
+          <p:cNvPr id="11" name="S360_COMPONENT_ID=rdm_logo|VARIANT=edge" descr="rdm_logo.png"/>
+          <p:cNvPicPr>
+            <a:picLocks noChangeAspect="1"/>
+          </p:cNvPicPr>
+          <p:nvPr/>
+        </p:nvPicPr>
+        <p:blipFill>
+          <a:blip r:embed="rId4"/>
+          <a:stretch>
+            <a:fillRect/>
+          </a:stretch>
+        </p:blipFill>
+        <p:spPr>
+          <a:xfrm>
+            <a:off x="6957441" y="1579245"/>
+            <a:ext cx="1428750" cy="590550"/>
+          </a:xfrm>
+          <a:prstGeom prst="rect">
+            <a:avLst/>
+          </a:prstGeom>
+        </p:spPr>
+      </p:pic>
+      <p:sp>
+        <p:nvSpPr>
+          <p:cNvPr id="12" name="TextBox 11"/>
+          <p:cNvSpPr txBox="1"/>
+          <p:nvPr/>
+        </p:nvSpPr>
+        <p:spPr>
+          <a:xfrm>
+            <a:off x="6355079" y="2907792"/>
+            <a:ext cx="2633472" cy="502920"/>
+          </a:xfrm>
+          <a:prstGeom prst="rect">
+            <a:avLst/>
+          </a:prstGeom>
+          <a:noFill/>
+        </p:spPr>
+        <p:txBody>
+          <a:bodyPr wrap="none">
+            <a:spAutoFit/>
+          </a:bodyPr>
+          <a:lstStyle/>
+          <a:p>
+            <a:pPr algn="ctr">
+              <a:defRPr sz="900" b="1">
+                <a:latin typeface="Arial"/>
+              </a:defRPr>
+            </a:pPr>
+            <a:r>
+              <a:t>RDM Logo</a:t>
+            </a:r>
+          </a:p>
+        </p:txBody>
+      </p:sp>
+      <p:sp>
+        <p:nvSpPr>
+          <p:cNvPr id="13" name="Rectangle 12"/>
+          <p:cNvSpPr/>
+          <p:nvPr/>
+        </p:nvSpPr>
+        <p:spPr>
+          <a:xfrm>
+            <a:off x="9226296" y="594360"/>
+            <a:ext cx="2889503" cy="2935224"/>
+          </a:xfrm>
+          <a:prstGeom prst="rect">
+            <a:avLst/>
+          </a:prstGeom>
+          <a:solidFill>
+            <a:srgbClr val="FAFBFD"/>
+          </a:solidFill>
+          <a:ln w="8890">
+            <a:solidFill>
+              <a:srgbClr val="D7DCE5"/>
+            </a:solidFill>
+          </a:ln>
+        </p:spPr>
+        <p:style>
+          <a:lnRef idx="1">
+            <a:schemeClr val="accent1"/>
+          </a:lnRef>
+          <a:fillRef idx="3">
+            <a:schemeClr val="accent1"/>
+          </a:fillRef>
+          <a:effectRef idx="2">
+            <a:schemeClr val="accent1"/>
+          </a:effectRef>
+          <a:fontRef idx="minor">
+            <a:schemeClr val="lt1"/>
+          </a:fontRef>
+        </p:style>
+        <p:txBody>
+          <a:bodyPr rtlCol="0" anchor="ctr"/>
+          <a:lstStyle/>
+          <a:p>
+            <a:pPr algn="ctr"/>
+          </a:p>
+        </p:txBody>
+      </p:sp>
+      <p:pic>
+        <p:nvPicPr>
+          <p:cNvPr id="14" name="S360_COMPONENT_ID=singh360_logo|VARIANT=edge" descr="singh360_logo.png"/>
+          <p:cNvPicPr>
+            <a:picLocks noChangeAspect="1"/>
+          </p:cNvPicPr>
+          <p:nvPr/>
+        </p:nvPicPr>
+        <p:blipFill>
+          <a:blip r:embed="rId5"/>
+          <a:stretch>
+            <a:fillRect/>
+          </a:stretch>
+        </p:blipFill>
+        <p:spPr>
+          <a:xfrm>
+            <a:off x="9956673" y="1579245"/>
+            <a:ext cx="1428750" cy="590550"/>
+          </a:xfrm>
+          <a:prstGeom prst="rect">
+            <a:avLst/>
+          </a:prstGeom>
+        </p:spPr>
+      </p:pic>
+      <p:sp>
+        <p:nvSpPr>
+          <p:cNvPr id="15" name="TextBox 14"/>
+          <p:cNvSpPr txBox="1"/>
+          <p:nvPr/>
+        </p:nvSpPr>
+        <p:spPr>
+          <a:xfrm>
+            <a:off x="9354312" y="2907792"/>
+            <a:ext cx="2633472" cy="502920"/>
+          </a:xfrm>
+          <a:prstGeom prst="rect">
+            <a:avLst/>
+          </a:prstGeom>
+          <a:noFill/>
+        </p:spPr>
+        <p:txBody>
+          <a:bodyPr wrap="none">
+            <a:spAutoFit/>
+          </a:bodyPr>
+          <a:lstStyle/>
+          <a:p>
+            <a:pPr algn="ctr">
+              <a:defRPr sz="900" b="1">
+                <a:latin typeface="Arial"/>
+              </a:defRPr>
+            </a:pPr>
+            <a:r>
+              <a:t>Singh360 Logo</a:t>
+            </a:r>
+          </a:p>
+        </p:txBody>
+      </p:sp>
+      <p:sp>
+        <p:nvSpPr>
+          <p:cNvPr id="16" name="Rectangle 15"/>
+          <p:cNvSpPr/>
+          <p:nvPr/>
+        </p:nvSpPr>
+        <p:spPr>
+          <a:xfrm>
+            <a:off x="12225528" y="594360"/>
+            <a:ext cx="2889503" cy="2935224"/>
+          </a:xfrm>
+          <a:prstGeom prst="rect">
+            <a:avLst/>
+          </a:prstGeom>
+          <a:solidFill>
+            <a:srgbClr val="FAFBFD"/>
+          </a:solidFill>
+          <a:ln w="8890">
+            <a:solidFill>
+              <a:srgbClr val="D7DCE5"/>
+            </a:solidFill>
+          </a:ln>
+        </p:spPr>
+        <p:style>
+          <a:lnRef idx="1">
+            <a:schemeClr val="accent1"/>
+          </a:lnRef>
+          <a:fillRef idx="3">
+            <a:schemeClr val="accent1"/>
+          </a:fillRef>
+          <a:effectRef idx="2">
+            <a:schemeClr val="accent1"/>
+          </a:effectRef>
+          <a:fontRef idx="minor">
+            <a:schemeClr val="lt1"/>
+          </a:fontRef>
+        </p:style>
+        <p:txBody>
+          <a:bodyPr rtlCol="0" anchor="ctr"/>
+          <a:lstStyle/>
+          <a:p>
+            <a:pPr algn="ctr"/>
+          </a:p>
+        </p:txBody>
+      </p:sp>
+      <p:pic>
+        <p:nvPicPr>
+          <p:cNvPr id="17" name="S360_COMPONENT_ID=logos_672af5074f|VARIANT=edge" descr="Singhg360_Logo.jpg"/>
+          <p:cNvPicPr>
+            <a:picLocks noChangeAspect="1"/>
+          </p:cNvPicPr>
+          <p:nvPr/>
+        </p:nvPicPr>
+        <p:blipFill>
+          <a:blip r:embed="rId6"/>
+          <a:stretch>
+            <a:fillRect/>
+          </a:stretch>
+        </p:blipFill>
+        <p:spPr>
+          <a:xfrm>
+            <a:off x="13003530" y="1588769"/>
+            <a:ext cx="1333500" cy="571500"/>
+          </a:xfrm>
+          <a:prstGeom prst="rect">
+            <a:avLst/>
+          </a:prstGeom>
+        </p:spPr>
+      </p:pic>
+      <p:sp>
+        <p:nvSpPr>
+          <p:cNvPr id="18" name="TextBox 17"/>
+          <p:cNvSpPr txBox="1"/>
+          <p:nvPr/>
+        </p:nvSpPr>
+        <p:spPr>
+          <a:xfrm>
+            <a:off x="12353544" y="2907792"/>
             <a:ext cx="2633472" cy="502920"/>
           </a:xfrm>
           <a:prstGeom prst="rect">
@@ -13424,7 +13731,7 @@
               </a:defRPr>
             </a:pPr>
             <a:r>
-              <a:t>RDM IDF Marker</a:t>
+              <a:t>rdm eepr electronic</a:t>
             </a:r>
           </a:p>
         </p:txBody>
@@ -13502,20 +13809,7 @@
               </a:defRPr>
             </a:pPr>
             <a:r>
-              <a:t>Signage Legend - Safety / Trapped / Leak</a:t>
-            </a:r>
-          </a:p>
-          <a:p>
-            <a:pPr algn="ctr">
-              <a:defRPr sz="700">
-                <a:solidFill>
-                  <a:srgbClr val="5F646E"/>
-                </a:solidFill>
-                <a:latin typeface="Arial"/>
-              </a:defRPr>
-            </a:pPr>
-            <a:r>
-              <a:t>Signage Legend</a:t>
+              <a:t>rdm eepr mechanical</a:t>
             </a:r>
           </a:p>
         </p:txBody>
@@ -13593,7 +13887,7 @@
               </a:defRPr>
             </a:pPr>
             <a:r>
-              <a:t>Signage Legend Safety</a:t>
+              <a:t>RDM IDF Marker</a:t>
             </a:r>
           </a:p>
         </p:txBody>
@@ -13643,9 +13937,178 @@
           </a:p>
         </p:txBody>
       </p:sp>
+      <p:sp>
+        <p:nvSpPr>
+          <p:cNvPr id="17" name="TextBox 16"/>
+          <p:cNvSpPr txBox="1"/>
+          <p:nvPr/>
+        </p:nvSpPr>
+        <p:spPr>
+          <a:xfrm>
+            <a:off x="3355848" y="5971031"/>
+            <a:ext cx="2633472" cy="502920"/>
+          </a:xfrm>
+          <a:prstGeom prst="rect">
+            <a:avLst/>
+          </a:prstGeom>
+          <a:noFill/>
+        </p:spPr>
+        <p:txBody>
+          <a:bodyPr wrap="none">
+            <a:spAutoFit/>
+          </a:bodyPr>
+          <a:lstStyle/>
+          <a:p>
+            <a:pPr algn="ctr">
+              <a:defRPr sz="900" b="1">
+                <a:latin typeface="Arial"/>
+              </a:defRPr>
+            </a:pPr>
+            <a:r>
+              <a:t>Signage Legend - Safety / Trapped / Leak</a:t>
+            </a:r>
+          </a:p>
+          <a:p>
+            <a:pPr algn="ctr">
+              <a:defRPr sz="700">
+                <a:solidFill>
+                  <a:srgbClr val="5F646E"/>
+                </a:solidFill>
+                <a:latin typeface="Arial"/>
+              </a:defRPr>
+            </a:pPr>
+            <a:r>
+              <a:t>Signage Legend</a:t>
+            </a:r>
+          </a:p>
+        </p:txBody>
+      </p:sp>
+      <p:sp>
+        <p:nvSpPr>
+          <p:cNvPr id="18" name="Rectangle 17"/>
+          <p:cNvSpPr/>
+          <p:nvPr/>
+        </p:nvSpPr>
+        <p:spPr>
+          <a:xfrm>
+            <a:off x="6227064" y="3657600"/>
+            <a:ext cx="2889503" cy="2935224"/>
+          </a:xfrm>
+          <a:prstGeom prst="rect">
+            <a:avLst/>
+          </a:prstGeom>
+          <a:solidFill>
+            <a:srgbClr val="FAFBFD"/>
+          </a:solidFill>
+          <a:ln w="8890">
+            <a:solidFill>
+              <a:srgbClr val="D7DCE5"/>
+            </a:solidFill>
+          </a:ln>
+        </p:spPr>
+        <p:style>
+          <a:lnRef idx="1">
+            <a:schemeClr val="accent1"/>
+          </a:lnRef>
+          <a:fillRef idx="3">
+            <a:schemeClr val="accent1"/>
+          </a:fillRef>
+          <a:effectRef idx="2">
+            <a:schemeClr val="accent1"/>
+          </a:effectRef>
+          <a:fontRef idx="minor">
+            <a:schemeClr val="lt1"/>
+          </a:fontRef>
+        </p:style>
+        <p:txBody>
+          <a:bodyPr rtlCol="0" anchor="ctr"/>
+          <a:lstStyle/>
+          <a:p>
+            <a:pPr algn="ctr"/>
+          </a:p>
+        </p:txBody>
+      </p:sp>
+      <p:sp>
+        <p:nvSpPr>
+          <p:cNvPr id="19" name="TextBox 18"/>
+          <p:cNvSpPr txBox="1"/>
+          <p:nvPr/>
+        </p:nvSpPr>
+        <p:spPr>
+          <a:xfrm>
+            <a:off x="6355079" y="5971031"/>
+            <a:ext cx="2633472" cy="502920"/>
+          </a:xfrm>
+          <a:prstGeom prst="rect">
+            <a:avLst/>
+          </a:prstGeom>
+          <a:noFill/>
+        </p:spPr>
+        <p:txBody>
+          <a:bodyPr wrap="none">
+            <a:spAutoFit/>
+          </a:bodyPr>
+          <a:lstStyle/>
+          <a:p>
+            <a:pPr algn="ctr">
+              <a:defRPr sz="900" b="1">
+                <a:latin typeface="Arial"/>
+              </a:defRPr>
+            </a:pPr>
+            <a:r>
+              <a:t>Signage Legend Safety</a:t>
+            </a:r>
+          </a:p>
+        </p:txBody>
+      </p:sp>
+      <p:sp>
+        <p:nvSpPr>
+          <p:cNvPr id="20" name="Rectangle 19"/>
+          <p:cNvSpPr/>
+          <p:nvPr/>
+        </p:nvSpPr>
+        <p:spPr>
+          <a:xfrm>
+            <a:off x="9226296" y="3657600"/>
+            <a:ext cx="2889503" cy="2935224"/>
+          </a:xfrm>
+          <a:prstGeom prst="rect">
+            <a:avLst/>
+          </a:prstGeom>
+          <a:solidFill>
+            <a:srgbClr val="FAFBFD"/>
+          </a:solidFill>
+          <a:ln w="8890">
+            <a:solidFill>
+              <a:srgbClr val="D7DCE5"/>
+            </a:solidFill>
+          </a:ln>
+        </p:spPr>
+        <p:style>
+          <a:lnRef idx="1">
+            <a:schemeClr val="accent1"/>
+          </a:lnRef>
+          <a:fillRef idx="3">
+            <a:schemeClr val="accent1"/>
+          </a:fillRef>
+          <a:effectRef idx="2">
+            <a:schemeClr val="accent1"/>
+          </a:effectRef>
+          <a:fontRef idx="minor">
+            <a:schemeClr val="lt1"/>
+          </a:fontRef>
+        </p:style>
+        <p:txBody>
+          <a:bodyPr rtlCol="0" anchor="ctr"/>
+          <a:lstStyle/>
+          <a:p>
+            <a:pPr algn="ctr"/>
+          </a:p>
+        </p:txBody>
+      </p:sp>
       <p:pic>
         <p:nvPicPr>
-          <p:cNvPr id="17" name="S360_COMPONENT_ID=signage_safety_51011bbb37|VARIANT=edge" descr="signage_legend_safety_trapped_leak_help.png"/>
+          <p:cNvPr id="21" name="S360_COMPONENT_ID=signage_safety_51011bbb37|VARIANT=edge" descr="signage_legend_safety_trapped_leak_help.png"/>
           <p:cNvPicPr>
             <a:picLocks noChangeAspect="1"/>
           </p:cNvPicPr>
@@ -13659,7 +14122,7 @@
         </p:blipFill>
         <p:spPr>
           <a:xfrm>
-            <a:off x="3434333" y="4080510"/>
+            <a:off x="9432798" y="4080510"/>
             <a:ext cx="2476500" cy="1714500"/>
           </a:xfrm>
           <a:prstGeom prst="rect">
@@ -13669,13 +14132,13 @@
       </p:pic>
       <p:sp>
         <p:nvSpPr>
-          <p:cNvPr id="18" name="TextBox 17"/>
+          <p:cNvPr id="22" name="TextBox 21"/>
           <p:cNvSpPr txBox="1"/>
           <p:nvPr/>
         </p:nvSpPr>
         <p:spPr>
           <a:xfrm>
-            <a:off x="3355848" y="5971031"/>
+            <a:off x="9354312" y="5971031"/>
             <a:ext cx="2633472" cy="502920"/>
           </a:xfrm>
           <a:prstGeom prst="rect">
@@ -13702,13 +14165,13 @@
       </p:sp>
       <p:sp>
         <p:nvSpPr>
-          <p:cNvPr id="19" name="Rectangle 18"/>
+          <p:cNvPr id="23" name="Rectangle 22"/>
           <p:cNvSpPr/>
           <p:nvPr/>
         </p:nvSpPr>
         <p:spPr>
           <a:xfrm>
-            <a:off x="6227064" y="3657600"/>
+            <a:off x="12225528" y="3657600"/>
             <a:ext cx="2889503" cy="2935224"/>
           </a:xfrm>
           <a:prstGeom prst="rect">
@@ -13747,13 +14210,13 @@
       </p:sp>
       <p:sp>
         <p:nvSpPr>
-          <p:cNvPr id="20" name="TextBox 19"/>
+          <p:cNvPr id="24" name="TextBox 23"/>
           <p:cNvSpPr txBox="1"/>
           <p:nvPr/>
         </p:nvSpPr>
         <p:spPr>
           <a:xfrm>
-            <a:off x="6355079" y="5971031"/>
+            <a:off x="12353544" y="5971031"/>
             <a:ext cx="2633472" cy="502920"/>
           </a:xfrm>
           <a:prstGeom prst="rect">
@@ -13793,13 +14256,13 @@
       </p:sp>
       <p:sp>
         <p:nvSpPr>
-          <p:cNvPr id="21" name="Rectangle 20"/>
+          <p:cNvPr id="25" name="Rectangle 24"/>
           <p:cNvSpPr/>
           <p:nvPr/>
         </p:nvSpPr>
         <p:spPr>
           <a:xfrm>
-            <a:off x="9226296" y="3657600"/>
+            <a:off x="228600" y="6720840"/>
             <a:ext cx="2889503" cy="2935224"/>
           </a:xfrm>
           <a:prstGeom prst="rect">
@@ -13838,13 +14301,13 @@
       </p:sp>
       <p:sp>
         <p:nvSpPr>
-          <p:cNvPr id="22" name="TextBox 21"/>
+          <p:cNvPr id="26" name="TextBox 25"/>
           <p:cNvSpPr txBox="1"/>
           <p:nvPr/>
         </p:nvSpPr>
         <p:spPr>
           <a:xfrm>
-            <a:off x="9354312" y="5971031"/>
+            <a:off x="356616" y="9034272"/>
             <a:ext cx="2633472" cy="502920"/>
           </a:xfrm>
           <a:prstGeom prst="rect">
@@ -13871,13 +14334,13 @@
       </p:sp>
       <p:sp>
         <p:nvSpPr>
-          <p:cNvPr id="23" name="Rectangle 22"/>
+          <p:cNvPr id="27" name="Rectangle 26"/>
           <p:cNvSpPr/>
           <p:nvPr/>
         </p:nvSpPr>
         <p:spPr>
           <a:xfrm>
-            <a:off x="12225528" y="3657600"/>
+            <a:off x="3227832" y="6720840"/>
             <a:ext cx="2889503" cy="2935224"/>
           </a:xfrm>
           <a:prstGeom prst="rect">
@@ -13916,13 +14379,13 @@
       </p:sp>
       <p:sp>
         <p:nvSpPr>
-          <p:cNvPr id="24" name="TextBox 23"/>
+          <p:cNvPr id="28" name="TextBox 27"/>
           <p:cNvSpPr txBox="1"/>
           <p:nvPr/>
         </p:nvSpPr>
         <p:spPr>
           <a:xfrm>
-            <a:off x="12353544" y="5971031"/>
+            <a:off x="3355848" y="9034272"/>
             <a:ext cx="2633472" cy="502920"/>
           </a:xfrm>
           <a:prstGeom prst="rect">
@@ -13949,13 +14412,13 @@
       </p:sp>
       <p:sp>
         <p:nvSpPr>
-          <p:cNvPr id="25" name="Rectangle 24"/>
+          <p:cNvPr id="29" name="Rectangle 28"/>
           <p:cNvSpPr/>
           <p:nvPr/>
         </p:nvSpPr>
         <p:spPr>
           <a:xfrm>
-            <a:off x="228600" y="6720840"/>
+            <a:off x="6227064" y="6720840"/>
             <a:ext cx="2889503" cy="2935224"/>
           </a:xfrm>
           <a:prstGeom prst="rect">
@@ -13994,13 +14457,13 @@
       </p:sp>
       <p:sp>
         <p:nvSpPr>
-          <p:cNvPr id="26" name="TextBox 25"/>
+          <p:cNvPr id="30" name="TextBox 29"/>
           <p:cNvSpPr txBox="1"/>
           <p:nvPr/>
         </p:nvSpPr>
         <p:spPr>
           <a:xfrm>
-            <a:off x="356616" y="9034272"/>
+            <a:off x="6355079" y="9034272"/>
             <a:ext cx="2633472" cy="502920"/>
           </a:xfrm>
           <a:prstGeom prst="rect">
@@ -14040,13 +14503,13 @@
       </p:sp>
       <p:sp>
         <p:nvSpPr>
-          <p:cNvPr id="27" name="Rectangle 26"/>
+          <p:cNvPr id="31" name="Rectangle 30"/>
           <p:cNvSpPr/>
           <p:nvPr/>
         </p:nvSpPr>
         <p:spPr>
           <a:xfrm>
-            <a:off x="3227832" y="6720840"/>
+            <a:off x="9226296" y="6720840"/>
             <a:ext cx="2889503" cy="2935224"/>
           </a:xfrm>
           <a:prstGeom prst="rect">
@@ -14085,13 +14548,13 @@
       </p:sp>
       <p:sp>
         <p:nvSpPr>
-          <p:cNvPr id="28" name="TextBox 27"/>
+          <p:cNvPr id="32" name="TextBox 31"/>
           <p:cNvSpPr txBox="1"/>
           <p:nvPr/>
         </p:nvSpPr>
         <p:spPr>
           <a:xfrm>
-            <a:off x="3355848" y="9034272"/>
+            <a:off x="9354312" y="9034272"/>
             <a:ext cx="2633472" cy="502920"/>
           </a:xfrm>
           <a:prstGeom prst="rect">
@@ -14118,13 +14581,13 @@
       </p:sp>
       <p:sp>
         <p:nvSpPr>
-          <p:cNvPr id="29" name="Rectangle 28"/>
+          <p:cNvPr id="33" name="Rectangle 32"/>
           <p:cNvSpPr/>
           <p:nvPr/>
         </p:nvSpPr>
         <p:spPr>
           <a:xfrm>
-            <a:off x="6227064" y="6720840"/>
+            <a:off x="12225528" y="6720840"/>
             <a:ext cx="2889503" cy="2935224"/>
           </a:xfrm>
           <a:prstGeom prst="rect">
@@ -14163,13 +14626,13 @@
       </p:sp>
       <p:sp>
         <p:nvSpPr>
-          <p:cNvPr id="30" name="TextBox 29"/>
+          <p:cNvPr id="34" name="TextBox 33"/>
           <p:cNvSpPr txBox="1"/>
           <p:nvPr/>
         </p:nvSpPr>
         <p:spPr>
           <a:xfrm>
-            <a:off x="6355079" y="9034272"/>
+            <a:off x="12353544" y="9034272"/>
             <a:ext cx="2633472" cy="502920"/>
           </a:xfrm>
           <a:prstGeom prst="rect">
@@ -14190,97 +14653,6 @@
             </a:pPr>
             <a:r>
               <a:t>When Lit Refrigerant Leak — Do Not Enter Sign</a:t>
-            </a:r>
-          </a:p>
-        </p:txBody>
-      </p:sp>
-      <p:sp>
-        <p:nvSpPr>
-          <p:cNvPr id="31" name="Rectangle 30"/>
-          <p:cNvSpPr/>
-          <p:nvPr/>
-        </p:nvSpPr>
-        <p:spPr>
-          <a:xfrm>
-            <a:off x="9226296" y="6720840"/>
-            <a:ext cx="2889503" cy="2935224"/>
-          </a:xfrm>
-          <a:prstGeom prst="rect">
-            <a:avLst/>
-          </a:prstGeom>
-          <a:solidFill>
-            <a:srgbClr val="FAFBFD"/>
-          </a:solidFill>
-          <a:ln w="8890">
-            <a:solidFill>
-              <a:srgbClr val="D7DCE5"/>
-            </a:solidFill>
-          </a:ln>
-        </p:spPr>
-        <p:style>
-          <a:lnRef idx="1">
-            <a:schemeClr val="accent1"/>
-          </a:lnRef>
-          <a:fillRef idx="3">
-            <a:schemeClr val="accent1"/>
-          </a:fillRef>
-          <a:effectRef idx="2">
-            <a:schemeClr val="accent1"/>
-          </a:effectRef>
-          <a:fontRef idx="minor">
-            <a:schemeClr val="lt1"/>
-          </a:fontRef>
-        </p:style>
-        <p:txBody>
-          <a:bodyPr rtlCol="0" anchor="ctr"/>
-          <a:lstStyle/>
-          <a:p>
-            <a:pPr algn="ctr"/>
-          </a:p>
-        </p:txBody>
-      </p:sp>
-      <p:sp>
-        <p:nvSpPr>
-          <p:cNvPr id="32" name="TextBox 31"/>
-          <p:cNvSpPr txBox="1"/>
-          <p:nvPr/>
-        </p:nvSpPr>
-        <p:spPr>
-          <a:xfrm>
-            <a:off x="9354312" y="9034272"/>
-            <a:ext cx="2633472" cy="502920"/>
-          </a:xfrm>
-          <a:prstGeom prst="rect">
-            <a:avLst/>
-          </a:prstGeom>
-          <a:noFill/>
-        </p:spPr>
-        <p:txBody>
-          <a:bodyPr wrap="none">
-            <a:spAutoFit/>
-          </a:bodyPr>
-          <a:lstStyle/>
-          <a:p>
-            <a:pPr algn="ctr">
-              <a:defRPr sz="900" b="1">
-                <a:latin typeface="Arial"/>
-              </a:defRPr>
-            </a:pPr>
-            <a:r>
-              <a:t>WICP Panel Marker</a:t>
-            </a:r>
-          </a:p>
-          <a:p>
-            <a:pPr algn="ctr">
-              <a:defRPr sz="700">
-                <a:solidFill>
-                  <a:srgbClr val="5F646E"/>
-                </a:solidFill>
-                <a:latin typeface="Arial"/>
-              </a:defRPr>
-            </a:pPr>
-            <a:r>
-              <a:t>WICP</a:t>
             </a:r>
           </a:p>
         </p:txBody>
@@ -15859,6 +16231,194 @@
             </a:pPr>
             <a:r>
               <a:t>RDM's Bluetooth</a:t>
+            </a:r>
+          </a:p>
+        </p:txBody>
+      </p:sp>
+    </p:spTree>
+  </p:cSld>
+  <p:clrMapOvr>
+    <a:masterClrMapping/>
+  </p:clrMapOvr>
+</p:sld>
+</file>
+
+<file path=ppt/slides/slide20.xml><?xml version="1.0" encoding="utf-8"?>
+<p:sld xmlns:a="http://schemas.openxmlformats.org/drawingml/2006/main" xmlns:p="http://schemas.openxmlformats.org/presentationml/2006/main" xmlns:r="http://schemas.openxmlformats.org/officeDocument/2006/relationships">
+  <p:cSld>
+    <p:spTree>
+      <p:nvGrpSpPr>
+        <p:cNvPr id="1" name=""/>
+        <p:cNvGrpSpPr/>
+        <p:nvPr/>
+      </p:nvGrpSpPr>
+      <p:grpSpPr/>
+      <p:sp>
+        <p:nvSpPr>
+          <p:cNvPr id="2" name="Rectangle 1"/>
+          <p:cNvSpPr/>
+          <p:nvPr/>
+        </p:nvSpPr>
+        <p:spPr>
+          <a:xfrm>
+            <a:off x="0" y="0"/>
+            <a:ext cx="15544800" cy="457200"/>
+          </a:xfrm>
+          <a:prstGeom prst="rect">
+            <a:avLst/>
+          </a:prstGeom>
+          <a:solidFill>
+            <a:srgbClr val="0C1730"/>
+          </a:solidFill>
+          <a:ln>
+            <a:noFill/>
+          </a:ln>
+        </p:spPr>
+        <p:style>
+          <a:lnRef idx="1">
+            <a:schemeClr val="accent1"/>
+          </a:lnRef>
+          <a:fillRef idx="3">
+            <a:schemeClr val="accent1"/>
+          </a:fillRef>
+          <a:effectRef idx="2">
+            <a:schemeClr val="accent1"/>
+          </a:effectRef>
+          <a:fontRef idx="minor">
+            <a:schemeClr val="lt1"/>
+          </a:fontRef>
+        </p:style>
+        <p:txBody>
+          <a:bodyPr rtlCol="0" anchor="ctr"/>
+          <a:lstStyle/>
+          <a:p>
+            <a:pPr algn="ctr"/>
+          </a:p>
+        </p:txBody>
+      </p:sp>
+      <p:sp>
+        <p:nvSpPr>
+          <p:cNvPr id="3" name="TextBox 2"/>
+          <p:cNvSpPr txBox="1"/>
+          <p:nvPr/>
+        </p:nvSpPr>
+        <p:spPr>
+          <a:xfrm>
+            <a:off x="274320" y="73152"/>
+            <a:ext cx="14996159" cy="274320"/>
+          </a:xfrm>
+          <a:prstGeom prst="rect">
+            <a:avLst/>
+          </a:prstGeom>
+          <a:noFill/>
+        </p:spPr>
+        <p:txBody>
+          <a:bodyPr wrap="none">
+            <a:spAutoFit/>
+          </a:bodyPr>
+          <a:lstStyle/>
+          <a:p>
+            <a:pPr algn="ctr">
+              <a:defRPr sz="1600" b="1">
+                <a:solidFill>
+                  <a:srgbClr val="FFFFFF"/>
+                </a:solidFill>
+                <a:latin typeface="Arial"/>
+              </a:defRPr>
+            </a:pPr>
+            <a:r>
+              <a:t>Symbols Markers — Edge Components</a:t>
+            </a:r>
+          </a:p>
+        </p:txBody>
+      </p:sp>
+      <p:sp>
+        <p:nvSpPr>
+          <p:cNvPr id="4" name="Rectangle 3"/>
+          <p:cNvSpPr/>
+          <p:nvPr/>
+        </p:nvSpPr>
+        <p:spPr>
+          <a:xfrm>
+            <a:off x="228600" y="594360"/>
+            <a:ext cx="2889503" cy="2935224"/>
+          </a:xfrm>
+          <a:prstGeom prst="rect">
+            <a:avLst/>
+          </a:prstGeom>
+          <a:solidFill>
+            <a:srgbClr val="FAFBFD"/>
+          </a:solidFill>
+          <a:ln w="8890">
+            <a:solidFill>
+              <a:srgbClr val="D7DCE5"/>
+            </a:solidFill>
+          </a:ln>
+        </p:spPr>
+        <p:style>
+          <a:lnRef idx="1">
+            <a:schemeClr val="accent1"/>
+          </a:lnRef>
+          <a:fillRef idx="3">
+            <a:schemeClr val="accent1"/>
+          </a:fillRef>
+          <a:effectRef idx="2">
+            <a:schemeClr val="accent1"/>
+          </a:effectRef>
+          <a:fontRef idx="minor">
+            <a:schemeClr val="lt1"/>
+          </a:fontRef>
+        </p:style>
+        <p:txBody>
+          <a:bodyPr rtlCol="0" anchor="ctr"/>
+          <a:lstStyle/>
+          <a:p>
+            <a:pPr algn="ctr"/>
+          </a:p>
+        </p:txBody>
+      </p:sp>
+      <p:sp>
+        <p:nvSpPr>
+          <p:cNvPr id="5" name="TextBox 4"/>
+          <p:cNvSpPr txBox="1"/>
+          <p:nvPr/>
+        </p:nvSpPr>
+        <p:spPr>
+          <a:xfrm>
+            <a:off x="356616" y="2907792"/>
+            <a:ext cx="2633472" cy="502920"/>
+          </a:xfrm>
+          <a:prstGeom prst="rect">
+            <a:avLst/>
+          </a:prstGeom>
+          <a:noFill/>
+        </p:spPr>
+        <p:txBody>
+          <a:bodyPr wrap="none">
+            <a:spAutoFit/>
+          </a:bodyPr>
+          <a:lstStyle/>
+          <a:p>
+            <a:pPr algn="ctr">
+              <a:defRPr sz="900" b="1">
+                <a:latin typeface="Arial"/>
+              </a:defRPr>
+            </a:pPr>
+            <a:r>
+              <a:t>WICP Panel Marker</a:t>
+            </a:r>
+          </a:p>
+          <a:p>
+            <a:pPr algn="ctr">
+              <a:defRPr sz="700">
+                <a:solidFill>
+                  <a:srgbClr val="5F646E"/>
+                </a:solidFill>
+                <a:latin typeface="Arial"/>
+              </a:defRPr>
+            </a:pPr>
+            <a:r>
+              <a:t>WICP</a:t>
             </a:r>
           </a:p>
         </p:txBody>

</xml_diff>